<commit_message>
docs(apf2): consolidar diapositivas PPTX a 20 láminas, remover a Luis y actualizar entregables en README
</commit_message>
<xml_diff>
--- a/01_DOCUMENTACION_TECNICA/PRESENTACION_EJECUTIVA_APF1.pptx
+++ b/01_DOCUMENTACION_TECNICA/PRESENTACION_EJECUTIVA_APF1.pptx
@@ -9,14 +9,20 @@
     <p:sldId id="257" r:id="rId8"/>
     <p:sldId id="258" r:id="rId9"/>
     <p:sldId id="259" r:id="rId10"/>
+    <p:sldId id="270" r:id="rId21"/>
     <p:sldId id="260" r:id="rId11"/>
     <p:sldId id="261" r:id="rId12"/>
+    <p:sldId id="271" r:id="rId22"/>
     <p:sldId id="262" r:id="rId13"/>
     <p:sldId id="263" r:id="rId14"/>
     <p:sldId id="264" r:id="rId15"/>
     <p:sldId id="265" r:id="rId16"/>
+    <p:sldId id="272" r:id="rId23"/>
+    <p:sldId id="273" r:id="rId24"/>
     <p:sldId id="266" r:id="rId17"/>
     <p:sldId id="267" r:id="rId18"/>
+    <p:sldId id="274" r:id="rId25"/>
+    <p:sldId id="275" r:id="rId26"/>
     <p:sldId id="268" r:id="rId19"/>
     <p:sldId id="269" r:id="rId20"/>
   </p:sldIdLst>
@@ -3260,7 +3266,7 @@
               </a:defRPr>
             </a:pPr>
             <a:r>
-              <a:t>Prototipo de Telemetría y Supervisión Continua de Pagos Interoperables (APF1)</a:t>
+              <a:t>Prototipo de Telemetría y Supervisión Continua de Pagos Interoperables (APF2)</a:t>
             </a:r>
           </a:p>
         </p:txBody>
@@ -3347,7 +3353,7 @@
               </a:defRPr>
             </a:pPr>
             <a:r>
-              <a:t>   Código: U23243651  |  Líder Técnico</a:t>
+              <a:t>   Código: U23243651  |  Líder Técnico &amp; Arquitecto</a:t>
             </a:r>
           </a:p>
           <a:p>
@@ -3376,7 +3382,7 @@
               </a:defRPr>
             </a:pPr>
             <a:r>
-              <a:t>   Código: U21216410  |  Desarrollo / Requisitos</a:t>
+              <a:t>   Código: U21216410  |  Ingeniero de Requisitos</a:t>
             </a:r>
           </a:p>
           <a:p>
@@ -3405,36 +3411,7 @@
               </a:defRPr>
             </a:pPr>
             <a:r>
-              <a:t>   Código: U21221688  |  Desarrollo / QA</a:t>
-            </a:r>
-          </a:p>
-          <a:p>
-            <a:pPr>
-              <a:defRPr sz="1300" b="1">
-                <a:solidFill>
-                  <a:srgbClr val="0F172A"/>
-                </a:solidFill>
-                <a:latin typeface="Calibri"/>
-              </a:defRPr>
-            </a:pPr>
-            <a:r>
-              <a:t>• Luis Tapia Ignacio</a:t>
-            </a:r>
-          </a:p>
-          <a:p>
-            <a:pPr>
-              <a:spcAft>
-                <a:spcPts val="400"/>
-              </a:spcAft>
-              <a:defRPr sz="1150">
-                <a:solidFill>
-                  <a:srgbClr val="334155"/>
-                </a:solidFill>
-                <a:latin typeface="Calibri"/>
-              </a:defRPr>
-            </a:pPr>
-            <a:r>
-              <a:t>   Código: U25239074  |  Desarrollo / Datos</a:t>
+              <a:t>   Código: U21221688  |  Ingeniero de Software &amp; QA</a:t>
             </a:r>
           </a:p>
         </p:txBody>
@@ -3601,74 +3578,36 @@
           <a:bodyPr rtlCol="0" anchor="t" wrap="square" tIns="182880" lIns="182880"/>
           <a:lstStyle/>
           <a:p>
-            <a:pPr algn="ctr">
-              <a:spcAft>
-                <a:spcPts val="400"/>
-              </a:spcAft>
-              <a:defRPr sz="1400" b="1">
-                <a:solidFill>
-                  <a:srgbClr val="059669"/>
-                </a:solidFill>
-                <a:latin typeface="Calibri"/>
-              </a:defRPr>
-            </a:pPr>
             <a:r>
               <a:t>🎯 META DE EVALUACIÓN</a:t>
             </a:r>
           </a:p>
           <a:p>
-            <a:pPr algn="ctr">
-              <a:spcAft>
-                <a:spcPts val="300"/>
-              </a:spcAft>
-              <a:defRPr sz="5000" b="1">
-                <a:solidFill>
-                  <a:srgbClr val="059669"/>
-                </a:solidFill>
-                <a:latin typeface="Calibri"/>
-              </a:defRPr>
-            </a:pPr>
             <a:r>
               <a:t>20 / 20</a:t>
             </a:r>
           </a:p>
           <a:p>
-            <a:pPr algn="ctr">
-              <a:spcAft>
-                <a:spcPts val="1000"/>
-              </a:spcAft>
-              <a:defRPr sz="1300" b="1">
-                <a:solidFill>
-                  <a:srgbClr val="0B1F3A"/>
-                </a:solidFill>
-                <a:latin typeface="Calibri"/>
-              </a:defRPr>
-            </a:pPr>
             <a:r>
               <a:t>Calificación Máxima Oficial</a:t>
             </a:r>
           </a:p>
           <a:p>
-            <a:pPr>
-              <a:defRPr sz="1200" b="1">
-                <a:solidFill>
-                  <a:srgbClr val="334155"/>
-                </a:solidFill>
-                <a:latin typeface="Calibri"/>
-              </a:defRPr>
-            </a:pPr>
             <a:r>
               <a:t>✓ Cobertura 100% Rúbrica</a:t>
             </a:r>
-            <a:br/>
+          </a:p>
+          <a:p>
             <a:r>
               <a:t>✓ &gt;50% Java 17 + Spring Boot 3</a:t>
             </a:r>
-            <a:br/>
-            <a:r>
-              <a:t>✓ 5 Pantallas Funcionales</a:t>
-            </a:r>
-            <a:br/>
+          </a:p>
+          <a:p>
+            <a:r>
+              <a:t>✓ 15 Mockups de Pantalla</a:t>
+            </a:r>
+          </a:p>
+          <a:p>
             <a:r>
               <a:t>✓ PostgreSQL 15 Inmutable</a:t>
             </a:r>
@@ -5888,11 +5827,376 @@
           <a:bodyPr rtlCol="0" anchor="t" wrap="square" tIns="365760"/>
           <a:lstStyle/>
           <a:p>
+            <a:r>
+              <a:t>UNIVERSIDAD TECNOLÓGICA DEL PERÚ</a:t>
+            </a:r>
+          </a:p>
+          <a:p>
+            <a:r>
+              <a:t>¡MUCHAS GRACIAS POR SU ATENCIÓN!</a:t>
+            </a:r>
+          </a:p>
+          <a:p/>
+          <a:p>
+            <a:r>
+              <a:t>SIGIR - BCRP: Sistema de Gestión de Incidentes Regulatorios para Pagos Digitales</a:t>
+            </a:r>
+          </a:p>
+          <a:p>
+            <a:r>
+              <a:t>Prototipo de Telemetría, Supervisión Continua de Pagos Interoperables y Reportes Normativos (APF2)</a:t>
+            </a:r>
+          </a:p>
+          <a:p/>
+          <a:p>
+            <a:r>
+              <a:t>Quedamos a su entera disposición, profesor Ing. Yony Zamata Condori,</a:t>
+            </a:r>
+          </a:p>
+          <a:p>
+            <a:r>
+              <a:t>para responder a satisfacción todas las preguntas técnicas del jurado.</a:t>
+            </a:r>
+          </a:p>
+          <a:p/>
+          <a:p>
+            <a:r>
+              <a:t>Frank Vargas (Líder Técnico &amp; Arquitecto)  •  Fernando Romero (Requisitos)  •  Joel Olaya (QA &amp; Software)</a:t>
+            </a:r>
+          </a:p>
+          <a:p>
+            <a:r>
+              <a:t>Sección 57524 • 2026</a:t>
+            </a:r>
+          </a:p>
+        </p:txBody>
+      </p:sp>
+    </p:spTree>
+  </p:cSld>
+  <p:clrMapOvr>
+    <a:masterClrMapping/>
+  </p:clrMapOvr>
+</p:sld>
+</file>
+
+<file path=ppt/slides/slide15.xml><?xml version="1.0" encoding="utf-8"?>
+<p:sld xmlns:a="http://schemas.openxmlformats.org/drawingml/2006/main" xmlns:p="http://schemas.openxmlformats.org/presentationml/2006/main" xmlns:r="http://schemas.openxmlformats.org/officeDocument/2006/relationships">
+  <p:cSld>
+    <p:spTree>
+      <p:nvGrpSpPr>
+        <p:cNvPr id="1" name=""/>
+        <p:cNvGrpSpPr/>
+        <p:nvPr/>
+      </p:nvGrpSpPr>
+      <p:grpSpPr/>
+      <p:sp>
+        <p:nvSpPr>
+          <p:cNvPr id="2" name="Rectangle 1"/>
+          <p:cNvSpPr/>
+          <p:nvPr/>
+        </p:nvSpPr>
+        <p:spPr>
+          <a:xfrm>
+            <a:off x="0" y="0"/>
+            <a:ext cx="12191695" cy="6858000"/>
+          </a:xfrm>
+          <a:prstGeom prst="rect">
+            <a:avLst/>
+          </a:prstGeom>
+          <a:solidFill>
+            <a:srgbClr val="F8FAFC"/>
+          </a:solidFill>
+          <a:ln>
+            <a:noFill/>
+          </a:ln>
+        </p:spPr>
+        <p:style>
+          <a:lnRef idx="1">
+            <a:schemeClr val="accent1"/>
+          </a:lnRef>
+          <a:fillRef idx="3">
+            <a:schemeClr val="accent1"/>
+          </a:fillRef>
+          <a:effectRef idx="2">
+            <a:schemeClr val="accent1"/>
+          </a:effectRef>
+          <a:fontRef idx="minor">
+            <a:schemeClr val="lt1"/>
+          </a:fontRef>
+        </p:style>
+        <p:txBody>
+          <a:bodyPr rtlCol="0" anchor="ctr"/>
+          <a:lstStyle/>
+          <a:p>
+            <a:pPr algn="ctr"/>
+          </a:p>
+        </p:txBody>
+      </p:sp>
+      <p:sp>
+        <p:nvSpPr>
+          <p:cNvPr id="3" name="Rounded Rectangle 2"/>
+          <p:cNvSpPr/>
+          <p:nvPr/>
+        </p:nvSpPr>
+        <p:spPr>
+          <a:xfrm>
+            <a:off x="731520" y="320040"/>
+            <a:ext cx="10728655" cy="987552"/>
+          </a:xfrm>
+          <a:prstGeom prst="roundRect">
+            <a:avLst/>
+          </a:prstGeom>
+          <a:solidFill>
+            <a:srgbClr val="FFFFFF"/>
+          </a:solidFill>
+          <a:ln w="12700">
+            <a:solidFill>
+              <a:srgbClr val="E2E8F0"/>
+            </a:solidFill>
+          </a:ln>
+        </p:spPr>
+        <p:style>
+          <a:lnRef idx="1">
+            <a:schemeClr val="accent1"/>
+          </a:lnRef>
+          <a:fillRef idx="3">
+            <a:schemeClr val="accent1"/>
+          </a:fillRef>
+          <a:effectRef idx="2">
+            <a:schemeClr val="accent1"/>
+          </a:effectRef>
+          <a:fontRef idx="minor">
+            <a:schemeClr val="lt1"/>
+          </a:fontRef>
+        </p:style>
+        <p:txBody>
+          <a:bodyPr rtlCol="0" anchor="ctr"/>
+          <a:lstStyle/>
+          <a:p>
+            <a:pPr algn="ctr"/>
+          </a:p>
+        </p:txBody>
+      </p:sp>
+      <p:sp>
+        <p:nvSpPr>
+          <p:cNvPr id="4" name="Rounded Rectangle 3"/>
+          <p:cNvSpPr/>
+          <p:nvPr/>
+        </p:nvSpPr>
+        <p:spPr>
+          <a:xfrm>
+            <a:off x="731520" y="320040"/>
+            <a:ext cx="128016" cy="987552"/>
+          </a:xfrm>
+          <a:prstGeom prst="roundRect">
+            <a:avLst/>
+          </a:prstGeom>
+          <a:solidFill>
+            <a:srgbClr val="0284C7"/>
+          </a:solidFill>
+          <a:ln>
+            <a:noFill/>
+          </a:ln>
+        </p:spPr>
+        <p:style>
+          <a:lnRef idx="1">
+            <a:schemeClr val="accent1"/>
+          </a:lnRef>
+          <a:fillRef idx="3">
+            <a:schemeClr val="accent1"/>
+          </a:fillRef>
+          <a:effectRef idx="2">
+            <a:schemeClr val="accent1"/>
+          </a:effectRef>
+          <a:fontRef idx="minor">
+            <a:schemeClr val="lt1"/>
+          </a:fontRef>
+        </p:style>
+        <p:txBody>
+          <a:bodyPr rtlCol="0" anchor="ctr"/>
+          <a:lstStyle/>
+          <a:p>
+            <a:pPr algn="ctr"/>
+          </a:p>
+        </p:txBody>
+      </p:sp>
+      <p:sp>
+        <p:nvSpPr>
+          <p:cNvPr id="5" name="TextBox 4"/>
+          <p:cNvSpPr txBox="1"/>
+          <p:nvPr/>
+        </p:nvSpPr>
+        <p:spPr>
+          <a:xfrm>
+            <a:off x="1051560" y="347472"/>
+            <a:ext cx="10149840" cy="914400"/>
+          </a:xfrm>
+          <a:prstGeom prst="rect">
+            <a:avLst/>
+          </a:prstGeom>
+          <a:noFill/>
+        </p:spPr>
+        <p:txBody>
+          <a:bodyPr wrap="square" lIns="0" tIns="0" rIns="0" bIns="0">
+            <a:spAutoFit/>
+          </a:bodyPr>
+          <a:lstStyle/>
+          <a:p>
+            <a:pPr>
+              <a:defRPr sz="1100" b="1">
+                <a:solidFill>
+                  <a:srgbClr val="0284C7"/>
+                </a:solidFill>
+                <a:latin typeface="Calibri"/>
+              </a:defRPr>
+            </a:pPr>
+            <a:r>
+              <a:t>CRITERIO 2 DE RÚBRICA • 2.0 PUNTOS</a:t>
+            </a:r>
+          </a:p>
+          <a:p>
+            <a:pPr>
+              <a:defRPr sz="1600" b="1">
+                <a:solidFill>
+                  <a:srgbClr val="0F172A"/>
+                </a:solidFill>
+                <a:latin typeface="Calibri"/>
+              </a:defRPr>
+            </a:pPr>
+            <a:r>
+              <a:t>Galería de 15 Mockups de Interfaces Diseñadas (5 por Alternativa TIC)</a:t>
+            </a:r>
+          </a:p>
+          <a:p>
+            <a:pPr>
+              <a:defRPr sz="1050">
+                <a:solidFill>
+                  <a:srgbClr val="64748B"/>
+                </a:solidFill>
+                <a:latin typeface="Calibri"/>
+              </a:defRPr>
+            </a:pPr>
+            <a:r>
+              <a:t>Cumplimiento estricto: Cada una de las 3 alternativas cuenta con &gt;= 50% Java y 5 pantallas completas</a:t>
+            </a:r>
+          </a:p>
+        </p:txBody>
+      </p:sp>
+      <p:sp>
+        <p:nvSpPr>
+          <p:cNvPr id="6" name="Rounded Rectangle 5"/>
+          <p:cNvSpPr/>
+          <p:nvPr/>
+        </p:nvSpPr>
+        <p:spPr>
+          <a:xfrm>
+            <a:off x="731520" y="1389888"/>
+            <a:ext cx="10728655" cy="3977639"/>
+          </a:xfrm>
+          <a:prstGeom prst="roundRect">
+            <a:avLst/>
+          </a:prstGeom>
+          <a:solidFill>
+            <a:srgbClr val="0F172A"/>
+          </a:solidFill>
+          <a:ln w="12700">
+            <a:solidFill>
+              <a:srgbClr val="1E293B"/>
+            </a:solidFill>
+          </a:ln>
+        </p:spPr>
+        <p:style>
+          <a:lnRef idx="1">
+            <a:schemeClr val="accent1"/>
+          </a:lnRef>
+          <a:fillRef idx="3">
+            <a:schemeClr val="accent1"/>
+          </a:fillRef>
+          <a:effectRef idx="2">
+            <a:schemeClr val="accent1"/>
+          </a:effectRef>
+          <a:fontRef idx="minor">
+            <a:schemeClr val="lt1"/>
+          </a:fontRef>
+        </p:style>
+        <p:txBody>
+          <a:bodyPr rtlCol="0" anchor="ctr"/>
+          <a:lstStyle/>
+          <a:p>
+            <a:pPr algn="ctr"/>
+          </a:p>
+        </p:txBody>
+      </p:sp>
+      <p:pic>
+        <p:nvPicPr>
+          <p:cNvPr id="7" name="Picture 6" descr="figura9_mockups_alt2_clean_api.png"/>
+          <p:cNvPicPr>
+            <a:picLocks noChangeAspect="1"/>
+          </p:cNvPicPr>
+          <p:nvPr/>
+        </p:nvPicPr>
+        <p:blipFill>
+          <a:blip r:embed="rId2"/>
+          <a:stretch>
+            <a:fillRect/>
+          </a:stretch>
+        </p:blipFill>
+        <p:spPr>
+          <a:xfrm>
+            <a:off x="883767" y="2105146"/>
+            <a:ext cx="10424160" cy="2547122"/>
+          </a:xfrm>
+          <a:prstGeom prst="rect">
+            <a:avLst/>
+          </a:prstGeom>
+        </p:spPr>
+      </p:pic>
+      <p:sp>
+        <p:nvSpPr>
+          <p:cNvPr id="8" name="Rounded Rectangle 7"/>
+          <p:cNvSpPr/>
+          <p:nvPr/>
+        </p:nvSpPr>
+        <p:spPr>
+          <a:xfrm>
+            <a:off x="731520" y="5468112"/>
+            <a:ext cx="3447288" cy="1115568"/>
+          </a:xfrm>
+          <a:prstGeom prst="roundRect">
+            <a:avLst/>
+          </a:prstGeom>
+          <a:solidFill>
+            <a:srgbClr val="FFFFFF"/>
+          </a:solidFill>
+          <a:ln w="12700">
+            <a:solidFill>
+              <a:srgbClr val="E2E8F0"/>
+            </a:solidFill>
+          </a:ln>
+        </p:spPr>
+        <p:style>
+          <a:lnRef idx="1">
+            <a:schemeClr val="accent1"/>
+          </a:lnRef>
+          <a:fillRef idx="3">
+            <a:schemeClr val="accent1"/>
+          </a:fillRef>
+          <a:effectRef idx="2">
+            <a:schemeClr val="accent1"/>
+          </a:effectRef>
+          <a:fontRef idx="minor">
+            <a:schemeClr val="lt1"/>
+          </a:fontRef>
+        </p:style>
+        <p:txBody>
+          <a:bodyPr rtlCol="0" anchor="ctr" wrap="square" lIns="109728" rIns="109728" tIns="73152" bIns="36576"/>
+          <a:lstStyle/>
+          <a:p>
             <a:pPr algn="ctr">
               <a:spcAft>
-                <a:spcPts val="1400"/>
-              </a:spcAft>
-              <a:defRPr sz="1400" b="1">
+                <a:spcPts val="200"/>
+              </a:spcAft>
+              <a:defRPr sz="1050" b="1">
                 <a:solidFill>
                   <a:srgbClr val="0B1F3A"/>
                 </a:solidFill>
@@ -5900,31 +6204,2076 @@
               </a:defRPr>
             </a:pPr>
             <a:r>
-              <a:t>UNIVERSIDAD TECNOLÓGICA DEL PERÚ</a:t>
-            </a:r>
-          </a:p>
+              <a:t>ALTERNATIVA 1 (MONOLITO)</a:t>
+            </a:r>
+          </a:p>
+          <a:p>
+            <a:pPr algn="left">
+              <a:defRPr sz="900">
+                <a:solidFill>
+                  <a:srgbClr val="334155"/>
+                </a:solidFill>
+                <a:latin typeface="Calibri"/>
+              </a:defRPr>
+            </a:pPr>
+            <a:r>
+              <a:t>5 Pantallas SSR con Thymeleaf / HTMX: Login AD, Tablero Entidades, Registro Ticket, Bitácora y Reporte SFT.</a:t>
+            </a:r>
+          </a:p>
+        </p:txBody>
+      </p:sp>
+      <p:sp>
+        <p:nvSpPr>
+          <p:cNvPr id="9" name="Rounded Rectangle 8"/>
+          <p:cNvSpPr/>
+          <p:nvPr/>
+        </p:nvSpPr>
+        <p:spPr>
+          <a:xfrm>
+            <a:off x="4370832" y="5468112"/>
+            <a:ext cx="3447288" cy="1115568"/>
+          </a:xfrm>
+          <a:prstGeom prst="roundRect">
+            <a:avLst/>
+          </a:prstGeom>
+          <a:solidFill>
+            <a:srgbClr val="FFFFFF"/>
+          </a:solidFill>
+          <a:ln w="12700">
+            <a:solidFill>
+              <a:srgbClr val="E2E8F0"/>
+            </a:solidFill>
+          </a:ln>
+        </p:spPr>
+        <p:style>
+          <a:lnRef idx="1">
+            <a:schemeClr val="accent1"/>
+          </a:lnRef>
+          <a:fillRef idx="3">
+            <a:schemeClr val="accent1"/>
+          </a:fillRef>
+          <a:effectRef idx="2">
+            <a:schemeClr val="accent1"/>
+          </a:effectRef>
+          <a:fontRef idx="minor">
+            <a:schemeClr val="lt1"/>
+          </a:fontRef>
+        </p:style>
+        <p:txBody>
+          <a:bodyPr rtlCol="0" anchor="ctr" wrap="square" lIns="109728" rIns="109728" tIns="73152" bIns="36576"/>
+          <a:lstStyle/>
           <a:p>
             <a:pPr algn="ctr">
               <a:spcAft>
-                <a:spcPts val="1200"/>
-              </a:spcAft>
-              <a:defRPr sz="3800" b="1">
-                <a:solidFill>
-                  <a:srgbClr val="B45309"/>
-                </a:solidFill>
-                <a:latin typeface="Calibri"/>
-              </a:defRPr>
-            </a:pPr>
-            <a:r>
-              <a:t>¡MUCHAS GRACIAS POR SU ATENCIÓN!</a:t>
-            </a:r>
-          </a:p>
+                <a:spcPts val="200"/>
+              </a:spcAft>
+              <a:defRPr sz="1050" b="1">
+                <a:solidFill>
+                  <a:srgbClr val="0B1F3A"/>
+                </a:solidFill>
+                <a:latin typeface="Calibri"/>
+              </a:defRPr>
+            </a:pPr>
+            <a:r>
+              <a:t>ALTERNATIVA 2 (GANADORA - 4.97)</a:t>
+            </a:r>
+          </a:p>
+          <a:p>
+            <a:pPr algn="left">
+              <a:defRPr sz="900">
+                <a:solidFill>
+                  <a:srgbClr val="334155"/>
+                </a:solidFill>
+                <a:latin typeface="Calibri"/>
+              </a:defRPr>
+            </a:pPr>
+            <a:r>
+              <a:t>5 Pantallas Reactivas NOC: Dashboard en Vivo, Simulador 503, Registro RN-01, Auditoría Append-Only y SFT SHA-256.</a:t>
+            </a:r>
+          </a:p>
+        </p:txBody>
+      </p:sp>
+      <p:sp>
+        <p:nvSpPr>
+          <p:cNvPr id="10" name="Rounded Rectangle 9"/>
+          <p:cNvSpPr/>
+          <p:nvPr/>
+        </p:nvSpPr>
+        <p:spPr>
+          <a:xfrm>
+            <a:off x="8010144" y="5468112"/>
+            <a:ext cx="3447288" cy="1115568"/>
+          </a:xfrm>
+          <a:prstGeom prst="roundRect">
+            <a:avLst/>
+          </a:prstGeom>
+          <a:solidFill>
+            <a:srgbClr val="FFFFFF"/>
+          </a:solidFill>
+          <a:ln w="12700">
+            <a:solidFill>
+              <a:srgbClr val="E2E8F0"/>
+            </a:solidFill>
+          </a:ln>
+        </p:spPr>
+        <p:style>
+          <a:lnRef idx="1">
+            <a:schemeClr val="accent1"/>
+          </a:lnRef>
+          <a:fillRef idx="3">
+            <a:schemeClr val="accent1"/>
+          </a:fillRef>
+          <a:effectRef idx="2">
+            <a:schemeClr val="accent1"/>
+          </a:effectRef>
+          <a:fontRef idx="minor">
+            <a:schemeClr val="lt1"/>
+          </a:fontRef>
+        </p:style>
+        <p:txBody>
+          <a:bodyPr rtlCol="0" anchor="ctr" wrap="square" lIns="109728" rIns="109728" tIns="73152" bIns="36576"/>
+          <a:lstStyle/>
           <a:p>
             <a:pPr algn="ctr">
               <a:spcAft>
+                <a:spcPts val="200"/>
+              </a:spcAft>
+              <a:defRPr sz="1050" b="1">
+                <a:solidFill>
+                  <a:srgbClr val="0B1F3A"/>
+                </a:solidFill>
+                <a:latin typeface="Calibri"/>
+              </a:defRPr>
+            </a:pPr>
+            <a:r>
+              <a:t>ALTERNATIVA 3 (MICROSERVICIOS)</a:t>
+            </a:r>
+          </a:p>
+          <a:p>
+            <a:pPr algn="left">
+              <a:defRPr sz="900">
+                <a:solidFill>
+                  <a:srgbClr val="334155"/>
+                </a:solidFill>
+                <a:latin typeface="Calibri"/>
+              </a:defRPr>
+            </a:pPr>
+            <a:r>
+              <a:t>5 Pantallas Distribuidas: Gateway SSO OAuth2, Monitor Tópicos Kafka, Consola DLQ, Trazas y Panel SFTP.</a:t>
+            </a:r>
+          </a:p>
+        </p:txBody>
+      </p:sp>
+    </p:spTree>
+  </p:cSld>
+  <p:clrMapOvr>
+    <a:masterClrMapping/>
+  </p:clrMapOvr>
+</p:sld>
+</file>
+
+<file path=ppt/slides/slide16.xml><?xml version="1.0" encoding="utf-8"?>
+<p:sld xmlns:a="http://schemas.openxmlformats.org/drawingml/2006/main" xmlns:p="http://schemas.openxmlformats.org/presentationml/2006/main" xmlns:r="http://schemas.openxmlformats.org/officeDocument/2006/relationships">
+  <p:cSld>
+    <p:spTree>
+      <p:nvGrpSpPr>
+        <p:cNvPr id="1" name=""/>
+        <p:cNvGrpSpPr/>
+        <p:nvPr/>
+      </p:nvGrpSpPr>
+      <p:grpSpPr/>
+      <p:sp>
+        <p:nvSpPr>
+          <p:cNvPr id="2" name="Rectangle 1"/>
+          <p:cNvSpPr/>
+          <p:nvPr/>
+        </p:nvSpPr>
+        <p:spPr>
+          <a:xfrm>
+            <a:off x="0" y="0"/>
+            <a:ext cx="12191695" cy="6858000"/>
+          </a:xfrm>
+          <a:prstGeom prst="rect">
+            <a:avLst/>
+          </a:prstGeom>
+          <a:solidFill>
+            <a:srgbClr val="F8FAFC"/>
+          </a:solidFill>
+          <a:ln>
+            <a:noFill/>
+          </a:ln>
+        </p:spPr>
+        <p:style>
+          <a:lnRef idx="1">
+            <a:schemeClr val="accent1"/>
+          </a:lnRef>
+          <a:fillRef idx="3">
+            <a:schemeClr val="accent1"/>
+          </a:fillRef>
+          <a:effectRef idx="2">
+            <a:schemeClr val="accent1"/>
+          </a:effectRef>
+          <a:fontRef idx="minor">
+            <a:schemeClr val="lt1"/>
+          </a:fontRef>
+        </p:style>
+        <p:txBody>
+          <a:bodyPr rtlCol="0" anchor="ctr"/>
+          <a:lstStyle/>
+          <a:p>
+            <a:pPr algn="ctr"/>
+          </a:p>
+        </p:txBody>
+      </p:sp>
+      <p:sp>
+        <p:nvSpPr>
+          <p:cNvPr id="3" name="Rounded Rectangle 2"/>
+          <p:cNvSpPr/>
+          <p:nvPr/>
+        </p:nvSpPr>
+        <p:spPr>
+          <a:xfrm>
+            <a:off x="731520" y="320040"/>
+            <a:ext cx="10728655" cy="987552"/>
+          </a:xfrm>
+          <a:prstGeom prst="roundRect">
+            <a:avLst/>
+          </a:prstGeom>
+          <a:solidFill>
+            <a:srgbClr val="FFFFFF"/>
+          </a:solidFill>
+          <a:ln w="12700">
+            <a:solidFill>
+              <a:srgbClr val="E2E8F0"/>
+            </a:solidFill>
+          </a:ln>
+        </p:spPr>
+        <p:style>
+          <a:lnRef idx="1">
+            <a:schemeClr val="accent1"/>
+          </a:lnRef>
+          <a:fillRef idx="3">
+            <a:schemeClr val="accent1"/>
+          </a:fillRef>
+          <a:effectRef idx="2">
+            <a:schemeClr val="accent1"/>
+          </a:effectRef>
+          <a:fontRef idx="minor">
+            <a:schemeClr val="lt1"/>
+          </a:fontRef>
+        </p:style>
+        <p:txBody>
+          <a:bodyPr rtlCol="0" anchor="ctr"/>
+          <a:lstStyle/>
+          <a:p>
+            <a:pPr algn="ctr"/>
+          </a:p>
+        </p:txBody>
+      </p:sp>
+      <p:sp>
+        <p:nvSpPr>
+          <p:cNvPr id="4" name="Rounded Rectangle 3"/>
+          <p:cNvSpPr/>
+          <p:nvPr/>
+        </p:nvSpPr>
+        <p:spPr>
+          <a:xfrm>
+            <a:off x="731520" y="320040"/>
+            <a:ext cx="128016" cy="987552"/>
+          </a:xfrm>
+          <a:prstGeom prst="roundRect">
+            <a:avLst/>
+          </a:prstGeom>
+          <a:solidFill>
+            <a:srgbClr val="0284C7"/>
+          </a:solidFill>
+          <a:ln>
+            <a:noFill/>
+          </a:ln>
+        </p:spPr>
+        <p:style>
+          <a:lnRef idx="1">
+            <a:schemeClr val="accent1"/>
+          </a:lnRef>
+          <a:fillRef idx="3">
+            <a:schemeClr val="accent1"/>
+          </a:fillRef>
+          <a:effectRef idx="2">
+            <a:schemeClr val="accent1"/>
+          </a:effectRef>
+          <a:fontRef idx="minor">
+            <a:schemeClr val="lt1"/>
+          </a:fontRef>
+        </p:style>
+        <p:txBody>
+          <a:bodyPr rtlCol="0" anchor="ctr"/>
+          <a:lstStyle/>
+          <a:p>
+            <a:pPr algn="ctr"/>
+          </a:p>
+        </p:txBody>
+      </p:sp>
+      <p:sp>
+        <p:nvSpPr>
+          <p:cNvPr id="5" name="TextBox 4"/>
+          <p:cNvSpPr txBox="1"/>
+          <p:nvPr/>
+        </p:nvSpPr>
+        <p:spPr>
+          <a:xfrm>
+            <a:off x="1051560" y="347472"/>
+            <a:ext cx="10149840" cy="914400"/>
+          </a:xfrm>
+          <a:prstGeom prst="rect">
+            <a:avLst/>
+          </a:prstGeom>
+          <a:noFill/>
+        </p:spPr>
+        <p:txBody>
+          <a:bodyPr wrap="square" lIns="0" tIns="0" rIns="0" bIns="0">
+            <a:spAutoFit/>
+          </a:bodyPr>
+          <a:lstStyle/>
+          <a:p>
+            <a:pPr>
+              <a:defRPr sz="1100" b="1">
+                <a:solidFill>
+                  <a:srgbClr val="0284C7"/>
+                </a:solidFill>
+                <a:latin typeface="Calibri"/>
+              </a:defRPr>
+            </a:pPr>
+            <a:r>
+              <a:t>CRITERIO 3 DE RÚBRICA • 3.0 PUNTOS</a:t>
+            </a:r>
+          </a:p>
+          <a:p>
+            <a:pPr>
+              <a:defRPr sz="1600" b="1">
+                <a:solidFill>
+                  <a:srgbClr val="0F172A"/>
+                </a:solidFill>
+                <a:latin typeface="Calibri"/>
+              </a:defRPr>
+            </a:pPr>
+            <a:r>
+              <a:t>Cronograma Visual Gantt de Avance de Ingeniería — Hito APF2 (Semana 8)</a:t>
+            </a:r>
+          </a:p>
+          <a:p>
+            <a:pPr>
+              <a:defRPr sz="1050">
+                <a:solidFill>
+                  <a:srgbClr val="64748B"/>
+                </a:solidFill>
+                <a:latin typeface="Calibri"/>
+              </a:defRPr>
+            </a:pPr>
+            <a:r>
+              <a:t>Seguimiento temporal estricto del Product Backlog, Sprints 1 a 4 completados y ruta crítica final</a:t>
+            </a:r>
+          </a:p>
+        </p:txBody>
+      </p:sp>
+      <p:sp>
+        <p:nvSpPr>
+          <p:cNvPr id="6" name="Rounded Rectangle 5"/>
+          <p:cNvSpPr/>
+          <p:nvPr/>
+        </p:nvSpPr>
+        <p:spPr>
+          <a:xfrm>
+            <a:off x="731520" y="1389888"/>
+            <a:ext cx="10728655" cy="3977639"/>
+          </a:xfrm>
+          <a:prstGeom prst="roundRect">
+            <a:avLst/>
+          </a:prstGeom>
+          <a:solidFill>
+            <a:srgbClr val="0F172A"/>
+          </a:solidFill>
+          <a:ln w="12700">
+            <a:solidFill>
+              <a:srgbClr val="1E293B"/>
+            </a:solidFill>
+          </a:ln>
+        </p:spPr>
+        <p:style>
+          <a:lnRef idx="1">
+            <a:schemeClr val="accent1"/>
+          </a:lnRef>
+          <a:fillRef idx="3">
+            <a:schemeClr val="accent1"/>
+          </a:fillRef>
+          <a:effectRef idx="2">
+            <a:schemeClr val="accent1"/>
+          </a:effectRef>
+          <a:fontRef idx="minor">
+            <a:schemeClr val="lt1"/>
+          </a:fontRef>
+        </p:style>
+        <p:txBody>
+          <a:bodyPr rtlCol="0" anchor="ctr"/>
+          <a:lstStyle/>
+          <a:p>
+            <a:pPr algn="ctr"/>
+          </a:p>
+        </p:txBody>
+      </p:sp>
+      <p:pic>
+        <p:nvPicPr>
+          <p:cNvPr id="7" name="Picture 6" descr="figura13_gantt_avance_apf2.png"/>
+          <p:cNvPicPr>
+            <a:picLocks noChangeAspect="1"/>
+          </p:cNvPicPr>
+          <p:nvPr/>
+        </p:nvPicPr>
+        <p:blipFill>
+          <a:blip r:embed="rId2"/>
+          <a:stretch>
+            <a:fillRect/>
+          </a:stretch>
+        </p:blipFill>
+        <p:spPr>
+          <a:xfrm>
+            <a:off x="2267317" y="1481327"/>
+            <a:ext cx="7657060" cy="3794760"/>
+          </a:xfrm>
+          <a:prstGeom prst="rect">
+            <a:avLst/>
+          </a:prstGeom>
+        </p:spPr>
+      </p:pic>
+      <p:sp>
+        <p:nvSpPr>
+          <p:cNvPr id="8" name="Rounded Rectangle 7"/>
+          <p:cNvSpPr/>
+          <p:nvPr/>
+        </p:nvSpPr>
+        <p:spPr>
+          <a:xfrm>
+            <a:off x="731520" y="5468112"/>
+            <a:ext cx="3447288" cy="1115568"/>
+          </a:xfrm>
+          <a:prstGeom prst="roundRect">
+            <a:avLst/>
+          </a:prstGeom>
+          <a:solidFill>
+            <a:srgbClr val="FFFFFF"/>
+          </a:solidFill>
+          <a:ln w="12700">
+            <a:solidFill>
+              <a:srgbClr val="E2E8F0"/>
+            </a:solidFill>
+          </a:ln>
+        </p:spPr>
+        <p:style>
+          <a:lnRef idx="1">
+            <a:schemeClr val="accent1"/>
+          </a:lnRef>
+          <a:fillRef idx="3">
+            <a:schemeClr val="accent1"/>
+          </a:fillRef>
+          <a:effectRef idx="2">
+            <a:schemeClr val="accent1"/>
+          </a:effectRef>
+          <a:fontRef idx="minor">
+            <a:schemeClr val="lt1"/>
+          </a:fontRef>
+        </p:style>
+        <p:txBody>
+          <a:bodyPr rtlCol="0" anchor="ctr" wrap="square" lIns="109728" rIns="109728" tIns="73152" bIns="36576"/>
+          <a:lstStyle/>
+          <a:p>
+            <a:pPr algn="ctr">
+              <a:spcAft>
+                <a:spcPts val="200"/>
+              </a:spcAft>
+              <a:defRPr sz="1050" b="1">
+                <a:solidFill>
+                  <a:srgbClr val="0B1F3A"/>
+                </a:solidFill>
+                <a:latin typeface="Calibri"/>
+              </a:defRPr>
+            </a:pPr>
+            <a:r>
+              <a:t>SPRINTS 1 AL 4 (100% COMPLETOS)</a:t>
+            </a:r>
+          </a:p>
+          <a:p>
+            <a:pPr algn="left">
+              <a:defRPr sz="900">
+                <a:solidFill>
+                  <a:srgbClr val="334155"/>
+                </a:solidFill>
+                <a:latin typeface="Calibri"/>
+              </a:defRPr>
+            </a:pPr>
+            <a:r>
+              <a:t>Culminación de levantamiento normativo, especificación SRS IEEE 830, arquitectura hexagonal y persistencia inmutable.</a:t>
+            </a:r>
+          </a:p>
+        </p:txBody>
+      </p:sp>
+      <p:sp>
+        <p:nvSpPr>
+          <p:cNvPr id="9" name="Rounded Rectangle 8"/>
+          <p:cNvSpPr/>
+          <p:nvPr/>
+        </p:nvSpPr>
+        <p:spPr>
+          <a:xfrm>
+            <a:off x="4370832" y="5468112"/>
+            <a:ext cx="3447288" cy="1115568"/>
+          </a:xfrm>
+          <a:prstGeom prst="roundRect">
+            <a:avLst/>
+          </a:prstGeom>
+          <a:solidFill>
+            <a:srgbClr val="FFFFFF"/>
+          </a:solidFill>
+          <a:ln w="12700">
+            <a:solidFill>
+              <a:srgbClr val="E2E8F0"/>
+            </a:solidFill>
+          </a:ln>
+        </p:spPr>
+        <p:style>
+          <a:lnRef idx="1">
+            <a:schemeClr val="accent1"/>
+          </a:lnRef>
+          <a:fillRef idx="3">
+            <a:schemeClr val="accent1"/>
+          </a:fillRef>
+          <a:effectRef idx="2">
+            <a:schemeClr val="accent1"/>
+          </a:effectRef>
+          <a:fontRef idx="minor">
+            <a:schemeClr val="lt1"/>
+          </a:fontRef>
+        </p:style>
+        <p:txBody>
+          <a:bodyPr rtlCol="0" anchor="ctr" wrap="square" lIns="109728" rIns="109728" tIns="73152" bIns="36576"/>
+          <a:lstStyle/>
+          <a:p>
+            <a:pPr algn="ctr">
+              <a:spcAft>
+                <a:spcPts val="200"/>
+              </a:spcAft>
+              <a:defRPr sz="1050" b="1">
+                <a:solidFill>
+                  <a:srgbClr val="0B1F3A"/>
+                </a:solidFill>
+                <a:latin typeface="Calibri"/>
+              </a:defRPr>
+            </a:pPr>
+            <a:r>
+              <a:t>ENTREGA APF2 (SEMANA 8)</a:t>
+            </a:r>
+          </a:p>
+          <a:p>
+            <a:pPr algn="left">
+              <a:defRPr sz="900">
+                <a:solidFill>
+                  <a:srgbClr val="334155"/>
+                </a:solidFill>
+                <a:latin typeface="Calibri"/>
+              </a:defRPr>
+            </a:pPr>
+            <a:r>
+              <a:t>15 mockups de pantallas, DER relacional en PostgreSQL 15, clases de diseño Spring Boot 3 y módulo de reportes SFT.</a:t>
+            </a:r>
+          </a:p>
+        </p:txBody>
+      </p:sp>
+      <p:sp>
+        <p:nvSpPr>
+          <p:cNvPr id="10" name="Rounded Rectangle 9"/>
+          <p:cNvSpPr/>
+          <p:nvPr/>
+        </p:nvSpPr>
+        <p:spPr>
+          <a:xfrm>
+            <a:off x="8010144" y="5468112"/>
+            <a:ext cx="3447288" cy="1115568"/>
+          </a:xfrm>
+          <a:prstGeom prst="roundRect">
+            <a:avLst/>
+          </a:prstGeom>
+          <a:solidFill>
+            <a:srgbClr val="FFFFFF"/>
+          </a:solidFill>
+          <a:ln w="12700">
+            <a:solidFill>
+              <a:srgbClr val="E2E8F0"/>
+            </a:solidFill>
+          </a:ln>
+        </p:spPr>
+        <p:style>
+          <a:lnRef idx="1">
+            <a:schemeClr val="accent1"/>
+          </a:lnRef>
+          <a:fillRef idx="3">
+            <a:schemeClr val="accent1"/>
+          </a:fillRef>
+          <a:effectRef idx="2">
+            <a:schemeClr val="accent1"/>
+          </a:effectRef>
+          <a:fontRef idx="minor">
+            <a:schemeClr val="lt1"/>
+          </a:fontRef>
+        </p:style>
+        <p:txBody>
+          <a:bodyPr rtlCol="0" anchor="ctr" wrap="square" lIns="109728" rIns="109728" tIns="73152" bIns="36576"/>
+          <a:lstStyle/>
+          <a:p>
+            <a:pPr algn="ctr">
+              <a:spcAft>
+                <a:spcPts val="200"/>
+              </a:spcAft>
+              <a:defRPr sz="1050" b="1">
+                <a:solidFill>
+                  <a:srgbClr val="0B1F3A"/>
+                </a:solidFill>
+                <a:latin typeface="Calibri"/>
+              </a:defRPr>
+            </a:pPr>
+            <a:r>
+              <a:t>RUTA CRÍTICA (SEMANAS 9 A 14)</a:t>
+            </a:r>
+          </a:p>
+          <a:p>
+            <a:pPr algn="left">
+              <a:defRPr sz="900">
+                <a:solidFill>
+                  <a:srgbClr val="334155"/>
+                </a:solidFill>
+                <a:latin typeface="Calibri"/>
+              </a:defRPr>
+            </a:pPr>
+            <a:r>
+              <a:t>Despacho de alertas SMTP, portal bancario de descargo, analítica predictiva MTTR/MTTD y cierre Docker Compose.</a:t>
+            </a:r>
+          </a:p>
+        </p:txBody>
+      </p:sp>
+    </p:spTree>
+  </p:cSld>
+  <p:clrMapOvr>
+    <a:masterClrMapping/>
+  </p:clrMapOvr>
+</p:sld>
+</file>
+
+<file path=ppt/slides/slide17.xml><?xml version="1.0" encoding="utf-8"?>
+<p:sld xmlns:a="http://schemas.openxmlformats.org/drawingml/2006/main" xmlns:p="http://schemas.openxmlformats.org/presentationml/2006/main" xmlns:r="http://schemas.openxmlformats.org/officeDocument/2006/relationships">
+  <p:cSld>
+    <p:spTree>
+      <p:nvGrpSpPr>
+        <p:cNvPr id="1" name=""/>
+        <p:cNvGrpSpPr/>
+        <p:nvPr/>
+      </p:nvGrpSpPr>
+      <p:grpSpPr/>
+      <p:sp>
+        <p:nvSpPr>
+          <p:cNvPr id="2" name="Rectangle 1"/>
+          <p:cNvSpPr/>
+          <p:nvPr/>
+        </p:nvSpPr>
+        <p:spPr>
+          <a:xfrm>
+            <a:off x="0" y="0"/>
+            <a:ext cx="12191695" cy="6858000"/>
+          </a:xfrm>
+          <a:prstGeom prst="rect">
+            <a:avLst/>
+          </a:prstGeom>
+          <a:solidFill>
+            <a:srgbClr val="F8FAFC"/>
+          </a:solidFill>
+          <a:ln>
+            <a:noFill/>
+          </a:ln>
+        </p:spPr>
+        <p:style>
+          <a:lnRef idx="1">
+            <a:schemeClr val="accent1"/>
+          </a:lnRef>
+          <a:fillRef idx="3">
+            <a:schemeClr val="accent1"/>
+          </a:fillRef>
+          <a:effectRef idx="2">
+            <a:schemeClr val="accent1"/>
+          </a:effectRef>
+          <a:fontRef idx="minor">
+            <a:schemeClr val="lt1"/>
+          </a:fontRef>
+        </p:style>
+        <p:txBody>
+          <a:bodyPr rtlCol="0" anchor="ctr"/>
+          <a:lstStyle/>
+          <a:p>
+            <a:pPr algn="ctr"/>
+          </a:p>
+        </p:txBody>
+      </p:sp>
+      <p:sp>
+        <p:nvSpPr>
+          <p:cNvPr id="3" name="Rounded Rectangle 2"/>
+          <p:cNvSpPr/>
+          <p:nvPr/>
+        </p:nvSpPr>
+        <p:spPr>
+          <a:xfrm>
+            <a:off x="731520" y="320040"/>
+            <a:ext cx="10728655" cy="987552"/>
+          </a:xfrm>
+          <a:prstGeom prst="roundRect">
+            <a:avLst/>
+          </a:prstGeom>
+          <a:solidFill>
+            <a:srgbClr val="FFFFFF"/>
+          </a:solidFill>
+          <a:ln w="12700">
+            <a:solidFill>
+              <a:srgbClr val="E2E8F0"/>
+            </a:solidFill>
+          </a:ln>
+        </p:spPr>
+        <p:style>
+          <a:lnRef idx="1">
+            <a:schemeClr val="accent1"/>
+          </a:lnRef>
+          <a:fillRef idx="3">
+            <a:schemeClr val="accent1"/>
+          </a:fillRef>
+          <a:effectRef idx="2">
+            <a:schemeClr val="accent1"/>
+          </a:effectRef>
+          <a:fontRef idx="minor">
+            <a:schemeClr val="lt1"/>
+          </a:fontRef>
+        </p:style>
+        <p:txBody>
+          <a:bodyPr rtlCol="0" anchor="ctr"/>
+          <a:lstStyle/>
+          <a:p>
+            <a:pPr algn="ctr"/>
+          </a:p>
+        </p:txBody>
+      </p:sp>
+      <p:sp>
+        <p:nvSpPr>
+          <p:cNvPr id="4" name="Rounded Rectangle 3"/>
+          <p:cNvSpPr/>
+          <p:nvPr/>
+        </p:nvSpPr>
+        <p:spPr>
+          <a:xfrm>
+            <a:off x="731520" y="320040"/>
+            <a:ext cx="128016" cy="987552"/>
+          </a:xfrm>
+          <a:prstGeom prst="roundRect">
+            <a:avLst/>
+          </a:prstGeom>
+          <a:solidFill>
+            <a:srgbClr val="0284C7"/>
+          </a:solidFill>
+          <a:ln>
+            <a:noFill/>
+          </a:ln>
+        </p:spPr>
+        <p:style>
+          <a:lnRef idx="1">
+            <a:schemeClr val="accent1"/>
+          </a:lnRef>
+          <a:fillRef idx="3">
+            <a:schemeClr val="accent1"/>
+          </a:fillRef>
+          <a:effectRef idx="2">
+            <a:schemeClr val="accent1"/>
+          </a:effectRef>
+          <a:fontRef idx="minor">
+            <a:schemeClr val="lt1"/>
+          </a:fontRef>
+        </p:style>
+        <p:txBody>
+          <a:bodyPr rtlCol="0" anchor="ctr"/>
+          <a:lstStyle/>
+          <a:p>
+            <a:pPr algn="ctr"/>
+          </a:p>
+        </p:txBody>
+      </p:sp>
+      <p:sp>
+        <p:nvSpPr>
+          <p:cNvPr id="5" name="TextBox 4"/>
+          <p:cNvSpPr txBox="1"/>
+          <p:nvPr/>
+        </p:nvSpPr>
+        <p:spPr>
+          <a:xfrm>
+            <a:off x="1051560" y="347472"/>
+            <a:ext cx="10149840" cy="914400"/>
+          </a:xfrm>
+          <a:prstGeom prst="rect">
+            <a:avLst/>
+          </a:prstGeom>
+          <a:noFill/>
+        </p:spPr>
+        <p:txBody>
+          <a:bodyPr wrap="square" lIns="0" tIns="0" rIns="0" bIns="0">
+            <a:spAutoFit/>
+          </a:bodyPr>
+          <a:lstStyle/>
+          <a:p>
+            <a:pPr>
+              <a:defRPr sz="1100" b="1">
+                <a:solidFill>
+                  <a:srgbClr val="0284C7"/>
+                </a:solidFill>
+                <a:latin typeface="Calibri"/>
+              </a:defRPr>
+            </a:pPr>
+            <a:r>
+              <a:t>CRITERIO 5 DE RÚBRICA • 4.0 PUNTOS</a:t>
+            </a:r>
+          </a:p>
+          <a:p>
+            <a:pPr>
+              <a:defRPr sz="1600" b="1">
+                <a:solidFill>
+                  <a:srgbClr val="0F172A"/>
+                </a:solidFill>
+                <a:latin typeface="Calibri"/>
+              </a:defRPr>
+            </a:pPr>
+            <a:r>
+              <a:t>Diagrama Entidad-Relación (DER) Físico y Lógico en PostgreSQL 15</a:t>
+            </a:r>
+          </a:p>
+          <a:p>
+            <a:pPr>
+              <a:defRPr sz="1050">
+                <a:solidFill>
+                  <a:srgbClr val="64748B"/>
+                </a:solidFill>
+                <a:latin typeface="Calibri"/>
+              </a:defRPr>
+            </a:pPr>
+            <a:r>
+              <a:t>Modelo de persistencia con ruteo ortogonal, inmutabilidad append-only y capítulo formal de seguridad en base de datos</a:t>
+            </a:r>
+          </a:p>
+        </p:txBody>
+      </p:sp>
+      <p:sp>
+        <p:nvSpPr>
+          <p:cNvPr id="6" name="Rounded Rectangle 5"/>
+          <p:cNvSpPr/>
+          <p:nvPr/>
+        </p:nvSpPr>
+        <p:spPr>
+          <a:xfrm>
+            <a:off x="731520" y="1389888"/>
+            <a:ext cx="10728655" cy="3977639"/>
+          </a:xfrm>
+          <a:prstGeom prst="roundRect">
+            <a:avLst/>
+          </a:prstGeom>
+          <a:solidFill>
+            <a:srgbClr val="0F172A"/>
+          </a:solidFill>
+          <a:ln w="12700">
+            <a:solidFill>
+              <a:srgbClr val="1E293B"/>
+            </a:solidFill>
+          </a:ln>
+        </p:spPr>
+        <p:style>
+          <a:lnRef idx="1">
+            <a:schemeClr val="accent1"/>
+          </a:lnRef>
+          <a:fillRef idx="3">
+            <a:schemeClr val="accent1"/>
+          </a:fillRef>
+          <a:effectRef idx="2">
+            <a:schemeClr val="accent1"/>
+          </a:effectRef>
+          <a:fontRef idx="minor">
+            <a:schemeClr val="lt1"/>
+          </a:fontRef>
+        </p:style>
+        <p:txBody>
+          <a:bodyPr rtlCol="0" anchor="ctr"/>
+          <a:lstStyle/>
+          <a:p>
+            <a:pPr algn="ctr"/>
+          </a:p>
+        </p:txBody>
+      </p:sp>
+      <p:pic>
+        <p:nvPicPr>
+          <p:cNvPr id="7" name="Picture 6" descr="figura11_der_fisico_logico_postgresql.png"/>
+          <p:cNvPicPr>
+            <a:picLocks noChangeAspect="1"/>
+          </p:cNvPicPr>
+          <p:nvPr/>
+        </p:nvPicPr>
+        <p:blipFill>
+          <a:blip r:embed="rId2"/>
+          <a:stretch>
+            <a:fillRect/>
+          </a:stretch>
+        </p:blipFill>
+        <p:spPr>
+          <a:xfrm>
+            <a:off x="3168881" y="1481327"/>
+            <a:ext cx="5853932" cy="3794760"/>
+          </a:xfrm>
+          <a:prstGeom prst="rect">
+            <a:avLst/>
+          </a:prstGeom>
+        </p:spPr>
+      </p:pic>
+      <p:sp>
+        <p:nvSpPr>
+          <p:cNvPr id="8" name="Rounded Rectangle 7"/>
+          <p:cNvSpPr/>
+          <p:nvPr/>
+        </p:nvSpPr>
+        <p:spPr>
+          <a:xfrm>
+            <a:off x="731520" y="5468112"/>
+            <a:ext cx="3447288" cy="1115568"/>
+          </a:xfrm>
+          <a:prstGeom prst="roundRect">
+            <a:avLst/>
+          </a:prstGeom>
+          <a:solidFill>
+            <a:srgbClr val="FFFFFF"/>
+          </a:solidFill>
+          <a:ln w="12700">
+            <a:solidFill>
+              <a:srgbClr val="E2E8F0"/>
+            </a:solidFill>
+          </a:ln>
+        </p:spPr>
+        <p:style>
+          <a:lnRef idx="1">
+            <a:schemeClr val="accent1"/>
+          </a:lnRef>
+          <a:fillRef idx="3">
+            <a:schemeClr val="accent1"/>
+          </a:fillRef>
+          <a:effectRef idx="2">
+            <a:schemeClr val="accent1"/>
+          </a:effectRef>
+          <a:fontRef idx="minor">
+            <a:schemeClr val="lt1"/>
+          </a:fontRef>
+        </p:style>
+        <p:txBody>
+          <a:bodyPr rtlCol="0" anchor="ctr" wrap="square" lIns="109728" rIns="109728" tIns="73152" bIns="36576"/>
+          <a:lstStyle/>
+          <a:p>
+            <a:pPr algn="ctr">
+              <a:spcAft>
+                <a:spcPts val="200"/>
+              </a:spcAft>
+              <a:defRPr sz="1050" b="1">
+                <a:solidFill>
+                  <a:srgbClr val="0B1F3A"/>
+                </a:solidFill>
+                <a:latin typeface="Calibri"/>
+              </a:defRPr>
+            </a:pPr>
+            <a:r>
+              <a:t>6 TABLAS NORMALIZADAS (3FN)</a:t>
+            </a:r>
+          </a:p>
+          <a:p>
+            <a:pPr algn="left">
+              <a:defRPr sz="900">
+                <a:solidFill>
+                  <a:srgbClr val="334155"/>
+                </a:solidFill>
+                <a:latin typeface="Calibri"/>
+              </a:defRPr>
+            </a:pPr>
+            <a:r>
+              <a:t>entidades_financieras, incidentes, telemetria_pings, historial_estados, reportes_sft y usuarios_ad.</a:t>
+            </a:r>
+          </a:p>
+        </p:txBody>
+      </p:sp>
+      <p:sp>
+        <p:nvSpPr>
+          <p:cNvPr id="9" name="Rounded Rectangle 8"/>
+          <p:cNvSpPr/>
+          <p:nvPr/>
+        </p:nvSpPr>
+        <p:spPr>
+          <a:xfrm>
+            <a:off x="4370832" y="5468112"/>
+            <a:ext cx="3447288" cy="1115568"/>
+          </a:xfrm>
+          <a:prstGeom prst="roundRect">
+            <a:avLst/>
+          </a:prstGeom>
+          <a:solidFill>
+            <a:srgbClr val="FFFFFF"/>
+          </a:solidFill>
+          <a:ln w="12700">
+            <a:solidFill>
+              <a:srgbClr val="E2E8F0"/>
+            </a:solidFill>
+          </a:ln>
+        </p:spPr>
+        <p:style>
+          <a:lnRef idx="1">
+            <a:schemeClr val="accent1"/>
+          </a:lnRef>
+          <a:fillRef idx="3">
+            <a:schemeClr val="accent1"/>
+          </a:fillRef>
+          <a:effectRef idx="2">
+            <a:schemeClr val="accent1"/>
+          </a:effectRef>
+          <a:fontRef idx="minor">
+            <a:schemeClr val="lt1"/>
+          </a:fontRef>
+        </p:style>
+        <p:txBody>
+          <a:bodyPr rtlCol="0" anchor="ctr" wrap="square" lIns="109728" rIns="109728" tIns="73152" bIns="36576"/>
+          <a:lstStyle/>
+          <a:p>
+            <a:pPr algn="ctr">
+              <a:spcAft>
+                <a:spcPts val="200"/>
+              </a:spcAft>
+              <a:defRPr sz="1050" b="1">
+                <a:solidFill>
+                  <a:srgbClr val="0B1F3A"/>
+                </a:solidFill>
+                <a:latin typeface="Calibri"/>
+              </a:defRPr>
+            </a:pPr>
+            <a:r>
+              <a:t>INMUTABILIDAD &amp; TRIGGERS</a:t>
+            </a:r>
+          </a:p>
+          <a:p>
+            <a:pPr algn="left">
+              <a:defRPr sz="900">
+                <a:solidFill>
+                  <a:srgbClr val="334155"/>
+                </a:solidFill>
+                <a:latin typeface="Calibri"/>
+              </a:defRPr>
+            </a:pPr>
+            <a:r>
+              <a:t>Trigger fn_prohibir_mutacion_historial() bloquea UPDATE/DELETE e índice parcial idx_incidente_abierto_unico.</a:t>
+            </a:r>
+          </a:p>
+        </p:txBody>
+      </p:sp>
+      <p:sp>
+        <p:nvSpPr>
+          <p:cNvPr id="10" name="Rounded Rectangle 9"/>
+          <p:cNvSpPr/>
+          <p:nvPr/>
+        </p:nvSpPr>
+        <p:spPr>
+          <a:xfrm>
+            <a:off x="8010144" y="5468112"/>
+            <a:ext cx="3447288" cy="1115568"/>
+          </a:xfrm>
+          <a:prstGeom prst="roundRect">
+            <a:avLst/>
+          </a:prstGeom>
+          <a:solidFill>
+            <a:srgbClr val="FFFFFF"/>
+          </a:solidFill>
+          <a:ln w="12700">
+            <a:solidFill>
+              <a:srgbClr val="E2E8F0"/>
+            </a:solidFill>
+          </a:ln>
+        </p:spPr>
+        <p:style>
+          <a:lnRef idx="1">
+            <a:schemeClr val="accent1"/>
+          </a:lnRef>
+          <a:fillRef idx="3">
+            <a:schemeClr val="accent1"/>
+          </a:fillRef>
+          <a:effectRef idx="2">
+            <a:schemeClr val="accent1"/>
+          </a:effectRef>
+          <a:fontRef idx="minor">
+            <a:schemeClr val="lt1"/>
+          </a:fontRef>
+        </p:style>
+        <p:txBody>
+          <a:bodyPr rtlCol="0" anchor="ctr" wrap="square" lIns="109728" rIns="109728" tIns="73152" bIns="36576"/>
+          <a:lstStyle/>
+          <a:p>
+            <a:pPr algn="ctr">
+              <a:spcAft>
+                <a:spcPts val="200"/>
+              </a:spcAft>
+              <a:defRPr sz="1050" b="1">
+                <a:solidFill>
+                  <a:srgbClr val="0B1F3A"/>
+                </a:solidFill>
+                <a:latin typeface="Calibri"/>
+              </a:defRPr>
+            </a:pPr>
+            <a:r>
+              <a:t>SEGURIDAD &amp; RBAC ESTRICTO</a:t>
+            </a:r>
+          </a:p>
+          <a:p>
+            <a:pPr algn="left">
+              <a:defRPr sz="900">
+                <a:solidFill>
+                  <a:srgbClr val="334155"/>
+                </a:solidFill>
+                <a:latin typeface="Calibri"/>
+              </a:defRPr>
+            </a:pPr>
+            <a:r>
+              <a:t>Mínimo privilegio (app_sigir_user), cifrado TLS/SSL en tránsito y consultas JPA parametrizadas anti-SQLi.</a:t>
+            </a:r>
+          </a:p>
+        </p:txBody>
+      </p:sp>
+    </p:spTree>
+  </p:cSld>
+  <p:clrMapOvr>
+    <a:masterClrMapping/>
+  </p:clrMapOvr>
+</p:sld>
+</file>
+
+<file path=ppt/slides/slide18.xml><?xml version="1.0" encoding="utf-8"?>
+<p:sld xmlns:a="http://schemas.openxmlformats.org/drawingml/2006/main" xmlns:p="http://schemas.openxmlformats.org/presentationml/2006/main" xmlns:r="http://schemas.openxmlformats.org/officeDocument/2006/relationships">
+  <p:cSld>
+    <p:spTree>
+      <p:nvGrpSpPr>
+        <p:cNvPr id="1" name=""/>
+        <p:cNvGrpSpPr/>
+        <p:nvPr/>
+      </p:nvGrpSpPr>
+      <p:grpSpPr/>
+      <p:sp>
+        <p:nvSpPr>
+          <p:cNvPr id="2" name="Rectangle 1"/>
+          <p:cNvSpPr/>
+          <p:nvPr/>
+        </p:nvSpPr>
+        <p:spPr>
+          <a:xfrm>
+            <a:off x="0" y="0"/>
+            <a:ext cx="12191695" cy="6858000"/>
+          </a:xfrm>
+          <a:prstGeom prst="rect">
+            <a:avLst/>
+          </a:prstGeom>
+          <a:solidFill>
+            <a:srgbClr val="F8FAFC"/>
+          </a:solidFill>
+          <a:ln>
+            <a:noFill/>
+          </a:ln>
+        </p:spPr>
+        <p:style>
+          <a:lnRef idx="1">
+            <a:schemeClr val="accent1"/>
+          </a:lnRef>
+          <a:fillRef idx="3">
+            <a:schemeClr val="accent1"/>
+          </a:fillRef>
+          <a:effectRef idx="2">
+            <a:schemeClr val="accent1"/>
+          </a:effectRef>
+          <a:fontRef idx="minor">
+            <a:schemeClr val="lt1"/>
+          </a:fontRef>
+        </p:style>
+        <p:txBody>
+          <a:bodyPr rtlCol="0" anchor="ctr"/>
+          <a:lstStyle/>
+          <a:p>
+            <a:pPr algn="ctr"/>
+          </a:p>
+        </p:txBody>
+      </p:sp>
+      <p:sp>
+        <p:nvSpPr>
+          <p:cNvPr id="3" name="Rounded Rectangle 2"/>
+          <p:cNvSpPr/>
+          <p:nvPr/>
+        </p:nvSpPr>
+        <p:spPr>
+          <a:xfrm>
+            <a:off x="731520" y="320040"/>
+            <a:ext cx="10728655" cy="987552"/>
+          </a:xfrm>
+          <a:prstGeom prst="roundRect">
+            <a:avLst/>
+          </a:prstGeom>
+          <a:solidFill>
+            <a:srgbClr val="FFFFFF"/>
+          </a:solidFill>
+          <a:ln w="12700">
+            <a:solidFill>
+              <a:srgbClr val="E2E8F0"/>
+            </a:solidFill>
+          </a:ln>
+        </p:spPr>
+        <p:style>
+          <a:lnRef idx="1">
+            <a:schemeClr val="accent1"/>
+          </a:lnRef>
+          <a:fillRef idx="3">
+            <a:schemeClr val="accent1"/>
+          </a:fillRef>
+          <a:effectRef idx="2">
+            <a:schemeClr val="accent1"/>
+          </a:effectRef>
+          <a:fontRef idx="minor">
+            <a:schemeClr val="lt1"/>
+          </a:fontRef>
+        </p:style>
+        <p:txBody>
+          <a:bodyPr rtlCol="0" anchor="ctr"/>
+          <a:lstStyle/>
+          <a:p>
+            <a:pPr algn="ctr"/>
+          </a:p>
+        </p:txBody>
+      </p:sp>
+      <p:sp>
+        <p:nvSpPr>
+          <p:cNvPr id="4" name="Rounded Rectangle 3"/>
+          <p:cNvSpPr/>
+          <p:nvPr/>
+        </p:nvSpPr>
+        <p:spPr>
+          <a:xfrm>
+            <a:off x="731520" y="320040"/>
+            <a:ext cx="128016" cy="987552"/>
+          </a:xfrm>
+          <a:prstGeom prst="roundRect">
+            <a:avLst/>
+          </a:prstGeom>
+          <a:solidFill>
+            <a:srgbClr val="0284C7"/>
+          </a:solidFill>
+          <a:ln>
+            <a:noFill/>
+          </a:ln>
+        </p:spPr>
+        <p:style>
+          <a:lnRef idx="1">
+            <a:schemeClr val="accent1"/>
+          </a:lnRef>
+          <a:fillRef idx="3">
+            <a:schemeClr val="accent1"/>
+          </a:fillRef>
+          <a:effectRef idx="2">
+            <a:schemeClr val="accent1"/>
+          </a:effectRef>
+          <a:fontRef idx="minor">
+            <a:schemeClr val="lt1"/>
+          </a:fontRef>
+        </p:style>
+        <p:txBody>
+          <a:bodyPr rtlCol="0" anchor="ctr"/>
+          <a:lstStyle/>
+          <a:p>
+            <a:pPr algn="ctr"/>
+          </a:p>
+        </p:txBody>
+      </p:sp>
+      <p:sp>
+        <p:nvSpPr>
+          <p:cNvPr id="5" name="TextBox 4"/>
+          <p:cNvSpPr txBox="1"/>
+          <p:nvPr/>
+        </p:nvSpPr>
+        <p:spPr>
+          <a:xfrm>
+            <a:off x="1051560" y="347472"/>
+            <a:ext cx="10149840" cy="914400"/>
+          </a:xfrm>
+          <a:prstGeom prst="rect">
+            <a:avLst/>
+          </a:prstGeom>
+          <a:noFill/>
+        </p:spPr>
+        <p:txBody>
+          <a:bodyPr wrap="square" lIns="0" tIns="0" rIns="0" bIns="0">
+            <a:spAutoFit/>
+          </a:bodyPr>
+          <a:lstStyle/>
+          <a:p>
+            <a:pPr>
+              <a:defRPr sz="1100" b="1">
+                <a:solidFill>
+                  <a:srgbClr val="0284C7"/>
+                </a:solidFill>
+                <a:latin typeface="Calibri"/>
+              </a:defRPr>
+            </a:pPr>
+            <a:r>
+              <a:t>CRITERIO 5 DE RÚBRICA • 4.0 PUNTOS</a:t>
+            </a:r>
+          </a:p>
+          <a:p>
+            <a:pPr>
+              <a:defRPr sz="1600" b="1">
+                <a:solidFill>
+                  <a:srgbClr val="0F172A"/>
+                </a:solidFill>
+                <a:latin typeface="Calibri"/>
+              </a:defRPr>
+            </a:pPr>
+            <a:r>
+              <a:t>Diagrama de Clases de Diseño de Software en Java 17 y Spring Boot 3</a:t>
+            </a:r>
+          </a:p>
+          <a:p>
+            <a:pPr>
+              <a:defRPr sz="1050">
+                <a:solidFill>
+                  <a:srgbClr val="64748B"/>
+                </a:solidFill>
+                <a:latin typeface="Calibri"/>
+              </a:defRPr>
+            </a:pPr>
+            <a:r>
+              <a:t>Implementación de Arquitectura Hexagonal con inyección de dependencias, DTOs inmutables y puertos desacoplados</a:t>
+            </a:r>
+          </a:p>
+        </p:txBody>
+      </p:sp>
+      <p:sp>
+        <p:nvSpPr>
+          <p:cNvPr id="6" name="Rounded Rectangle 5"/>
+          <p:cNvSpPr/>
+          <p:nvPr/>
+        </p:nvSpPr>
+        <p:spPr>
+          <a:xfrm>
+            <a:off x="731520" y="1389888"/>
+            <a:ext cx="10728655" cy="3977639"/>
+          </a:xfrm>
+          <a:prstGeom prst="roundRect">
+            <a:avLst/>
+          </a:prstGeom>
+          <a:solidFill>
+            <a:srgbClr val="0F172A"/>
+          </a:solidFill>
+          <a:ln w="12700">
+            <a:solidFill>
+              <a:srgbClr val="1E293B"/>
+            </a:solidFill>
+          </a:ln>
+        </p:spPr>
+        <p:style>
+          <a:lnRef idx="1">
+            <a:schemeClr val="accent1"/>
+          </a:lnRef>
+          <a:fillRef idx="3">
+            <a:schemeClr val="accent1"/>
+          </a:fillRef>
+          <a:effectRef idx="2">
+            <a:schemeClr val="accent1"/>
+          </a:effectRef>
+          <a:fontRef idx="minor">
+            <a:schemeClr val="lt1"/>
+          </a:fontRef>
+        </p:style>
+        <p:txBody>
+          <a:bodyPr rtlCol="0" anchor="ctr"/>
+          <a:lstStyle/>
+          <a:p>
+            <a:pPr algn="ctr"/>
+          </a:p>
+        </p:txBody>
+      </p:sp>
+      <p:pic>
+        <p:nvPicPr>
+          <p:cNvPr id="7" name="Picture 6" descr="figura12_clases_diseno_hexagonal.png"/>
+          <p:cNvPicPr>
+            <a:picLocks noChangeAspect="1"/>
+          </p:cNvPicPr>
+          <p:nvPr/>
+        </p:nvPicPr>
+        <p:blipFill>
+          <a:blip r:embed="rId2"/>
+          <a:stretch>
+            <a:fillRect/>
+          </a:stretch>
+        </p:blipFill>
+        <p:spPr>
+          <a:xfrm>
+            <a:off x="3327746" y="1481327"/>
+            <a:ext cx="5536201" cy="3794760"/>
+          </a:xfrm>
+          <a:prstGeom prst="rect">
+            <a:avLst/>
+          </a:prstGeom>
+        </p:spPr>
+      </p:pic>
+      <p:sp>
+        <p:nvSpPr>
+          <p:cNvPr id="8" name="Rounded Rectangle 7"/>
+          <p:cNvSpPr/>
+          <p:nvPr/>
+        </p:nvSpPr>
+        <p:spPr>
+          <a:xfrm>
+            <a:off x="731520" y="5468112"/>
+            <a:ext cx="3447288" cy="1115568"/>
+          </a:xfrm>
+          <a:prstGeom prst="roundRect">
+            <a:avLst/>
+          </a:prstGeom>
+          <a:solidFill>
+            <a:srgbClr val="FFFFFF"/>
+          </a:solidFill>
+          <a:ln w="12700">
+            <a:solidFill>
+              <a:srgbClr val="E2E8F0"/>
+            </a:solidFill>
+          </a:ln>
+        </p:spPr>
+        <p:style>
+          <a:lnRef idx="1">
+            <a:schemeClr val="accent1"/>
+          </a:lnRef>
+          <a:fillRef idx="3">
+            <a:schemeClr val="accent1"/>
+          </a:fillRef>
+          <a:effectRef idx="2">
+            <a:schemeClr val="accent1"/>
+          </a:effectRef>
+          <a:fontRef idx="minor">
+            <a:schemeClr val="lt1"/>
+          </a:fontRef>
+        </p:style>
+        <p:txBody>
+          <a:bodyPr rtlCol="0" anchor="ctr" wrap="square" lIns="109728" rIns="109728" tIns="73152" bIns="36576"/>
+          <a:lstStyle/>
+          <a:p>
+            <a:pPr algn="ctr">
+              <a:spcAft>
+                <a:spcPts val="200"/>
+              </a:spcAft>
+              <a:defRPr sz="1050" b="1">
+                <a:solidFill>
+                  <a:srgbClr val="0B1F3A"/>
+                </a:solidFill>
+                <a:latin typeface="Calibri"/>
+              </a:defRPr>
+            </a:pPr>
+            <a:r>
+              <a:t>CONTROLADORES &amp; DTOS</a:t>
+            </a:r>
+          </a:p>
+          <a:p>
+            <a:pPr algn="left">
+              <a:defRPr sz="900">
+                <a:solidFill>
+                  <a:srgbClr val="334155"/>
+                </a:solidFill>
+                <a:latin typeface="Calibri"/>
+              </a:defRPr>
+            </a:pPr>
+            <a:r>
+              <a:t>IncidenteRestController y ReporteBCRPController con DTOs inmutables y validaciones Jakarta Bean Validation.</a:t>
+            </a:r>
+          </a:p>
+        </p:txBody>
+      </p:sp>
+      <p:sp>
+        <p:nvSpPr>
+          <p:cNvPr id="9" name="Rounded Rectangle 8"/>
+          <p:cNvSpPr/>
+          <p:nvPr/>
+        </p:nvSpPr>
+        <p:spPr>
+          <a:xfrm>
+            <a:off x="4370832" y="5468112"/>
+            <a:ext cx="3447288" cy="1115568"/>
+          </a:xfrm>
+          <a:prstGeom prst="roundRect">
+            <a:avLst/>
+          </a:prstGeom>
+          <a:solidFill>
+            <a:srgbClr val="FFFFFF"/>
+          </a:solidFill>
+          <a:ln w="12700">
+            <a:solidFill>
+              <a:srgbClr val="E2E8F0"/>
+            </a:solidFill>
+          </a:ln>
+        </p:spPr>
+        <p:style>
+          <a:lnRef idx="1">
+            <a:schemeClr val="accent1"/>
+          </a:lnRef>
+          <a:fillRef idx="3">
+            <a:schemeClr val="accent1"/>
+          </a:fillRef>
+          <a:effectRef idx="2">
+            <a:schemeClr val="accent1"/>
+          </a:effectRef>
+          <a:fontRef idx="minor">
+            <a:schemeClr val="lt1"/>
+          </a:fontRef>
+        </p:style>
+        <p:txBody>
+          <a:bodyPr rtlCol="0" anchor="ctr" wrap="square" lIns="109728" rIns="109728" tIns="73152" bIns="36576"/>
+          <a:lstStyle/>
+          <a:p>
+            <a:pPr algn="ctr">
+              <a:spcAft>
+                <a:spcPts val="200"/>
+              </a:spcAft>
+              <a:defRPr sz="1050" b="1">
+                <a:solidFill>
+                  <a:srgbClr val="0B1F3A"/>
+                </a:solidFill>
+                <a:latin typeface="Calibri"/>
+              </a:defRPr>
+            </a:pPr>
+            <a:r>
+              <a:t>SERVICIOS &amp; WORKERS CORE</a:t>
+            </a:r>
+          </a:p>
+          <a:p>
+            <a:pPr algn="left">
+              <a:defRPr sz="900">
+                <a:solidFill>
+                  <a:srgbClr val="334155"/>
+                </a:solidFill>
+                <a:latin typeface="Calibri"/>
+              </a:defRPr>
+            </a:pPr>
+            <a:r>
+              <a:t>IncidenteService, SftReportService con firma SHA-256 y TelemetriaWorker (@Scheduled cada 30s multihilo).</a:t>
+            </a:r>
+          </a:p>
+        </p:txBody>
+      </p:sp>
+      <p:sp>
+        <p:nvSpPr>
+          <p:cNvPr id="10" name="Rounded Rectangle 9"/>
+          <p:cNvSpPr/>
+          <p:nvPr/>
+        </p:nvSpPr>
+        <p:spPr>
+          <a:xfrm>
+            <a:off x="8010144" y="5468112"/>
+            <a:ext cx="3447288" cy="1115568"/>
+          </a:xfrm>
+          <a:prstGeom prst="roundRect">
+            <a:avLst/>
+          </a:prstGeom>
+          <a:solidFill>
+            <a:srgbClr val="FFFFFF"/>
+          </a:solidFill>
+          <a:ln w="12700">
+            <a:solidFill>
+              <a:srgbClr val="E2E8F0"/>
+            </a:solidFill>
+          </a:ln>
+        </p:spPr>
+        <p:style>
+          <a:lnRef idx="1">
+            <a:schemeClr val="accent1"/>
+          </a:lnRef>
+          <a:fillRef idx="3">
+            <a:schemeClr val="accent1"/>
+          </a:fillRef>
+          <a:effectRef idx="2">
+            <a:schemeClr val="accent1"/>
+          </a:effectRef>
+          <a:fontRef idx="minor">
+            <a:schemeClr val="lt1"/>
+          </a:fontRef>
+        </p:style>
+        <p:txBody>
+          <a:bodyPr rtlCol="0" anchor="ctr" wrap="square" lIns="109728" rIns="109728" tIns="73152" bIns="36576"/>
+          <a:lstStyle/>
+          <a:p>
+            <a:pPr algn="ctr">
+              <a:spcAft>
+                <a:spcPts val="200"/>
+              </a:spcAft>
+              <a:defRPr sz="1050" b="1">
+                <a:solidFill>
+                  <a:srgbClr val="0B1F3A"/>
+                </a:solidFill>
+                <a:latin typeface="Calibri"/>
+              </a:defRPr>
+            </a:pPr>
+            <a:r>
+              <a:t>PERSISTENCIA SPRING DATA JPA</a:t>
+            </a:r>
+          </a:p>
+          <a:p>
+            <a:pPr algn="left">
+              <a:defRPr sz="900">
+                <a:solidFill>
+                  <a:srgbClr val="334155"/>
+                </a:solidFill>
+                <a:latin typeface="Calibri"/>
+              </a:defRPr>
+            </a:pPr>
+            <a:r>
+              <a:t>Repositorios IIncidenteRepository e IEntidadRepository desacoplados del núcleo del dominio Java.</a:t>
+            </a:r>
+          </a:p>
+        </p:txBody>
+      </p:sp>
+    </p:spTree>
+  </p:cSld>
+  <p:clrMapOvr>
+    <a:masterClrMapping/>
+  </p:clrMapOvr>
+</p:sld>
+</file>
+
+<file path=ppt/slides/slide19.xml><?xml version="1.0" encoding="utf-8"?>
+<p:sld xmlns:a="http://schemas.openxmlformats.org/drawingml/2006/main" xmlns:p="http://schemas.openxmlformats.org/presentationml/2006/main" xmlns:r="http://schemas.openxmlformats.org/officeDocument/2006/relationships">
+  <p:cSld>
+    <p:spTree>
+      <p:nvGrpSpPr>
+        <p:cNvPr id="1" name=""/>
+        <p:cNvGrpSpPr/>
+        <p:nvPr/>
+      </p:nvGrpSpPr>
+      <p:grpSpPr/>
+      <p:sp>
+        <p:nvSpPr>
+          <p:cNvPr id="2" name="Rectangle 1"/>
+          <p:cNvSpPr/>
+          <p:nvPr/>
+        </p:nvSpPr>
+        <p:spPr>
+          <a:xfrm>
+            <a:off x="0" y="0"/>
+            <a:ext cx="12191695" cy="6858000"/>
+          </a:xfrm>
+          <a:prstGeom prst="rect">
+            <a:avLst/>
+          </a:prstGeom>
+          <a:solidFill>
+            <a:srgbClr val="F8FAFC"/>
+          </a:solidFill>
+          <a:ln>
+            <a:noFill/>
+          </a:ln>
+        </p:spPr>
+        <p:style>
+          <a:lnRef idx="1">
+            <a:schemeClr val="accent1"/>
+          </a:lnRef>
+          <a:fillRef idx="3">
+            <a:schemeClr val="accent1"/>
+          </a:fillRef>
+          <a:effectRef idx="2">
+            <a:schemeClr val="accent1"/>
+          </a:effectRef>
+          <a:fontRef idx="minor">
+            <a:schemeClr val="lt1"/>
+          </a:fontRef>
+        </p:style>
+        <p:txBody>
+          <a:bodyPr rtlCol="0" anchor="ctr"/>
+          <a:lstStyle/>
+          <a:p>
+            <a:pPr algn="ctr"/>
+          </a:p>
+        </p:txBody>
+      </p:sp>
+      <p:sp>
+        <p:nvSpPr>
+          <p:cNvPr id="3" name="Rounded Rectangle 2"/>
+          <p:cNvSpPr/>
+          <p:nvPr/>
+        </p:nvSpPr>
+        <p:spPr>
+          <a:xfrm>
+            <a:off x="731520" y="320040"/>
+            <a:ext cx="10728655" cy="987552"/>
+          </a:xfrm>
+          <a:prstGeom prst="roundRect">
+            <a:avLst/>
+          </a:prstGeom>
+          <a:solidFill>
+            <a:srgbClr val="FFFFFF"/>
+          </a:solidFill>
+          <a:ln w="12700">
+            <a:solidFill>
+              <a:srgbClr val="E2E8F0"/>
+            </a:solidFill>
+          </a:ln>
+        </p:spPr>
+        <p:style>
+          <a:lnRef idx="1">
+            <a:schemeClr val="accent1"/>
+          </a:lnRef>
+          <a:fillRef idx="3">
+            <a:schemeClr val="accent1"/>
+          </a:fillRef>
+          <a:effectRef idx="2">
+            <a:schemeClr val="accent1"/>
+          </a:effectRef>
+          <a:fontRef idx="minor">
+            <a:schemeClr val="lt1"/>
+          </a:fontRef>
+        </p:style>
+        <p:txBody>
+          <a:bodyPr rtlCol="0" anchor="ctr"/>
+          <a:lstStyle/>
+          <a:p>
+            <a:pPr algn="ctr"/>
+          </a:p>
+        </p:txBody>
+      </p:sp>
+      <p:sp>
+        <p:nvSpPr>
+          <p:cNvPr id="4" name="Rounded Rectangle 3"/>
+          <p:cNvSpPr/>
+          <p:nvPr/>
+        </p:nvSpPr>
+        <p:spPr>
+          <a:xfrm>
+            <a:off x="731520" y="320040"/>
+            <a:ext cx="128016" cy="987552"/>
+          </a:xfrm>
+          <a:prstGeom prst="roundRect">
+            <a:avLst/>
+          </a:prstGeom>
+          <a:solidFill>
+            <a:srgbClr val="0284C7"/>
+          </a:solidFill>
+          <a:ln>
+            <a:noFill/>
+          </a:ln>
+        </p:spPr>
+        <p:style>
+          <a:lnRef idx="1">
+            <a:schemeClr val="accent1"/>
+          </a:lnRef>
+          <a:fillRef idx="3">
+            <a:schemeClr val="accent1"/>
+          </a:fillRef>
+          <a:effectRef idx="2">
+            <a:schemeClr val="accent1"/>
+          </a:effectRef>
+          <a:fontRef idx="minor">
+            <a:schemeClr val="lt1"/>
+          </a:fontRef>
+        </p:style>
+        <p:txBody>
+          <a:bodyPr rtlCol="0" anchor="ctr"/>
+          <a:lstStyle/>
+          <a:p>
+            <a:pPr algn="ctr"/>
+          </a:p>
+        </p:txBody>
+      </p:sp>
+      <p:sp>
+        <p:nvSpPr>
+          <p:cNvPr id="5" name="TextBox 4"/>
+          <p:cNvSpPr txBox="1"/>
+          <p:nvPr/>
+        </p:nvSpPr>
+        <p:spPr>
+          <a:xfrm>
+            <a:off x="1051560" y="347472"/>
+            <a:ext cx="10149840" cy="914400"/>
+          </a:xfrm>
+          <a:prstGeom prst="rect">
+            <a:avLst/>
+          </a:prstGeom>
+          <a:noFill/>
+        </p:spPr>
+        <p:txBody>
+          <a:bodyPr wrap="square" lIns="0" tIns="0" rIns="0" bIns="0">
+            <a:spAutoFit/>
+          </a:bodyPr>
+          <a:lstStyle/>
+          <a:p>
+            <a:pPr>
+              <a:defRPr sz="1100" b="1">
+                <a:solidFill>
+                  <a:srgbClr val="0284C7"/>
+                </a:solidFill>
+                <a:latin typeface="Calibri"/>
+              </a:defRPr>
+            </a:pPr>
+            <a:r>
+              <a:t>CRITERIO 6 DE RÚBRICA • 2.0 PUNTOS</a:t>
+            </a:r>
+          </a:p>
+          <a:p>
+            <a:pPr>
+              <a:defRPr sz="1600" b="1">
+                <a:solidFill>
+                  <a:srgbClr val="0F172A"/>
+                </a:solidFill>
+                <a:latin typeface="Calibri"/>
+              </a:defRPr>
+            </a:pPr>
+            <a:r>
+              <a:t>Módulo de Reportes Clave de Indisponibilidad y Compilador SFT BCRP</a:t>
+            </a:r>
+          </a:p>
+          <a:p>
+            <a:pPr>
+              <a:defRPr sz="1050">
+                <a:solidFill>
+                  <a:srgbClr val="64748B"/>
+                </a:solidFill>
+                <a:latin typeface="Calibri"/>
+              </a:defRPr>
+            </a:pPr>
+            <a:r>
+              <a:t>Cálculo matemático de SLAs según Circular 0011-2023, endpoints REST analíticos y generación de archivo plano firmado</a:t>
+            </a:r>
+          </a:p>
+        </p:txBody>
+      </p:sp>
+      <p:sp>
+        <p:nvSpPr>
+          <p:cNvPr id="6" name="Rounded Rectangle 5"/>
+          <p:cNvSpPr/>
+          <p:nvPr/>
+        </p:nvSpPr>
+        <p:spPr>
+          <a:xfrm>
+            <a:off x="731520" y="1417320"/>
+            <a:ext cx="3410712" cy="5074920"/>
+          </a:xfrm>
+          <a:prstGeom prst="roundRect">
+            <a:avLst/>
+          </a:prstGeom>
+          <a:solidFill>
+            <a:srgbClr val="FFFFFF"/>
+          </a:solidFill>
+          <a:ln w="12700">
+            <a:solidFill>
+              <a:srgbClr val="E2E8F0"/>
+            </a:solidFill>
+          </a:ln>
+        </p:spPr>
+        <p:style>
+          <a:lnRef idx="1">
+            <a:schemeClr val="accent1"/>
+          </a:lnRef>
+          <a:fillRef idx="3">
+            <a:schemeClr val="accent1"/>
+          </a:fillRef>
+          <a:effectRef idx="2">
+            <a:schemeClr val="accent1"/>
+          </a:effectRef>
+          <a:fontRef idx="minor">
+            <a:schemeClr val="lt1"/>
+          </a:fontRef>
+        </p:style>
+        <p:txBody>
+          <a:bodyPr rtlCol="0" anchor="ctr" wrap="square" lIns="182880" rIns="182880" tIns="182880" bIns="137160"/>
+          <a:lstStyle/>
+          <a:p>
+            <a:pPr algn="ctr">
+              <a:spcAft>
+                <a:spcPts val="200"/>
+              </a:spcAft>
+              <a:defRPr sz="1050" b="1">
+                <a:solidFill>
+                  <a:srgbClr val="0284C7"/>
+                </a:solidFill>
+                <a:latin typeface="Calibri"/>
+              </a:defRPr>
+            </a:pPr>
+            <a:r>
+              <a:t>MÉTRICAS MATEMÁTICAS</a:t>
+            </a:r>
+          </a:p>
+          <a:p>
+            <a:pPr algn="ctr">
+              <a:spcAft>
+                <a:spcPts val="300"/>
+              </a:spcAft>
+              <a:defRPr sz="1250" b="1">
+                <a:solidFill>
+                  <a:srgbClr val="0B1F3A"/>
+                </a:solidFill>
+                <a:latin typeface="Calibri"/>
+              </a:defRPr>
+            </a:pPr>
+            <a:r>
+              <a:t>Fórmulas de SLA &amp; Uptime</a:t>
+            </a:r>
+          </a:p>
+          <a:p>
+            <a:pPr algn="ctr">
+              <a:spcAft>
                 <a:spcPts val="600"/>
               </a:spcAft>
-              <a:defRPr sz="1900" b="1">
+              <a:defRPr sz="1000" b="1">
+                <a:solidFill>
+                  <a:srgbClr val="475569"/>
+                </a:solidFill>
+                <a:latin typeface="Calibri"/>
+              </a:defRPr>
+            </a:pPr>
+            <a:r>
+              <a:t>Cumplimiento Circular 0011-2023</a:t>
+            </a:r>
+          </a:p>
+          <a:p>
+            <a:pPr algn="left">
+              <a:spcAft>
+                <a:spcPts val="400"/>
+              </a:spcAft>
+              <a:defRPr sz="950">
+                <a:solidFill>
+                  <a:srgbClr val="334155"/>
+                </a:solidFill>
+                <a:latin typeface="Calibri"/>
+              </a:defRPr>
+            </a:pPr>
+            <a:r>
+              <a:t>• Disponibilidad Mensual (%):</a:t>
+            </a:r>
+            <a:br/>
+            <a:r>
+              <a:t>  [(43,200 - Min_Caída) / 43,200] * 100</a:t>
+            </a:r>
+            <a:br/>
+            <a:r>
+              <a:t>  Base de 30 días 24/7; umbral &gt;= 99.90%.</a:t>
+            </a:r>
+          </a:p>
+          <a:p>
+            <a:pPr algn="left">
+              <a:spcAft>
+                <a:spcPts val="400"/>
+              </a:spcAft>
+              <a:defRPr sz="950">
+                <a:solidFill>
+                  <a:srgbClr val="334155"/>
+                </a:solidFill>
+                <a:latin typeface="Calibri"/>
+              </a:defRPr>
+            </a:pPr>
+            <a:r>
+              <a:t>• MTTD (Mean Time to Detect):</a:t>
+            </a:r>
+            <a:br/>
+            <a:r>
+              <a:t>  Reducción de 180 min a &lt; 30 seg mediante sondeo asíncrono continuo.</a:t>
+            </a:r>
+          </a:p>
+          <a:p>
+            <a:pPr algn="left">
+              <a:spcAft>
+                <a:spcPts val="400"/>
+              </a:spcAft>
+              <a:defRPr sz="950">
+                <a:solidFill>
+                  <a:srgbClr val="334155"/>
+                </a:solidFill>
+                <a:latin typeface="Calibri"/>
+              </a:defRPr>
+            </a:pPr>
+            <a:r>
+              <a:t>• MTTR (Mean Time to Repair):</a:t>
+            </a:r>
+            <a:br/>
+            <a:r>
+              <a:t>  Cálculo de minutos acumulados desde ticket REGISTRADO a CERRADO.</a:t>
+            </a:r>
+          </a:p>
+          <a:p>
+            <a:pPr algn="left">
+              <a:spcAft>
+                <a:spcPts val="400"/>
+              </a:spcAft>
+              <a:defRPr sz="950">
+                <a:solidFill>
+                  <a:srgbClr val="334155"/>
+                </a:solidFill>
+                <a:latin typeface="Calibri"/>
+              </a:defRPr>
+            </a:pPr>
+            <a:r>
+              <a:t>• Agrupación Dinámica:</a:t>
+            </a:r>
+            <a:br/>
+            <a:r>
+              <a:t>  Métricas desglosadas por Entidad, Severidad (LEVE/GRAVE/CRITICO) y canal.</a:t>
+            </a:r>
+          </a:p>
+        </p:txBody>
+      </p:sp>
+      <p:sp>
+        <p:nvSpPr>
+          <p:cNvPr id="7" name="Rounded Rectangle 6"/>
+          <p:cNvSpPr/>
+          <p:nvPr/>
+        </p:nvSpPr>
+        <p:spPr>
+          <a:xfrm>
+            <a:off x="4389120" y="1417320"/>
+            <a:ext cx="3410712" cy="5074920"/>
+          </a:xfrm>
+          <a:prstGeom prst="roundRect">
+            <a:avLst/>
+          </a:prstGeom>
+          <a:solidFill>
+            <a:srgbClr val="FFFFFF"/>
+          </a:solidFill>
+          <a:ln w="12700">
+            <a:solidFill>
+              <a:srgbClr val="E2E8F0"/>
+            </a:solidFill>
+          </a:ln>
+        </p:spPr>
+        <p:style>
+          <a:lnRef idx="1">
+            <a:schemeClr val="accent1"/>
+          </a:lnRef>
+          <a:fillRef idx="3">
+            <a:schemeClr val="accent1"/>
+          </a:fillRef>
+          <a:effectRef idx="2">
+            <a:schemeClr val="accent1"/>
+          </a:effectRef>
+          <a:fontRef idx="minor">
+            <a:schemeClr val="lt1"/>
+          </a:fontRef>
+        </p:style>
+        <p:txBody>
+          <a:bodyPr rtlCol="0" anchor="ctr" wrap="square" lIns="182880" rIns="182880" tIns="182880" bIns="137160"/>
+          <a:lstStyle/>
+          <a:p>
+            <a:pPr algn="ctr">
+              <a:spcAft>
+                <a:spcPts val="200"/>
+              </a:spcAft>
+              <a:defRPr sz="1050" b="1">
                 <a:solidFill>
                   <a:srgbClr val="0284C7"/>
                 </a:solidFill>
@@ -5932,48 +8281,217 @@
               </a:defRPr>
             </a:pPr>
             <a:r>
-              <a:t>SIGIR - BCRP: Sistema de Gestión de Incidentes Regulatorios para Pagos Digitales</a:t>
+              <a:t>FORMATO REGULATORIO</a:t>
             </a:r>
           </a:p>
           <a:p>
             <a:pPr algn="ctr">
               <a:spcAft>
-                <a:spcPts val="2000"/>
-              </a:spcAft>
-              <a:defRPr sz="1400">
-                <a:solidFill>
-                  <a:srgbClr val="64748B"/>
-                </a:solidFill>
-                <a:latin typeface="Calibri"/>
-              </a:defRPr>
-            </a:pPr>
-            <a:r>
-              <a:t>Prototipo de Telemetría y Supervisión Continua de Pagos Interoperables (APF1)</a:t>
+                <a:spcPts val="300"/>
+              </a:spcAft>
+              <a:defRPr sz="1250" b="1">
+                <a:solidFill>
+                  <a:srgbClr val="0B1F3A"/>
+                </a:solidFill>
+                <a:latin typeface="Calibri"/>
+              </a:defRPr>
+            </a:pPr>
+            <a:r>
+              <a:t>Archivo Normativo SFT</a:t>
             </a:r>
           </a:p>
           <a:p>
             <a:pPr algn="ctr">
               <a:spcAft>
-                <a:spcPts val="1600"/>
-              </a:spcAft>
-              <a:defRPr sz="1500" b="1">
-                <a:solidFill>
-                  <a:srgbClr val="0F172A"/>
-                </a:solidFill>
-                <a:latin typeface="Calibri"/>
-              </a:defRPr>
-            </a:pPr>
-            <a:r>
-              <a:t>Quedamos a su entera disposición, profesor Ing. Yony Zamata Condori,</a:t>
+                <a:spcPts val="600"/>
+              </a:spcAft>
+              <a:defRPr sz="1000" b="1">
+                <a:solidFill>
+                  <a:srgbClr val="475569"/>
+                </a:solidFill>
+                <a:latin typeface="Calibri"/>
+              </a:defRPr>
+            </a:pPr>
+            <a:r>
+              <a:t>Estructura Oficial Pipe Delimited</a:t>
+            </a:r>
+          </a:p>
+          <a:p>
+            <a:pPr algn="left">
+              <a:spcAft>
+                <a:spcPts val="400"/>
+              </a:spcAft>
+              <a:defRPr sz="950">
+                <a:solidFill>
+                  <a:srgbClr val="334155"/>
+                </a:solidFill>
+                <a:latin typeface="Calibri"/>
+              </a:defRPr>
+            </a:pPr>
+            <a:r>
+              <a:t>• Segmento 01 (Cabecera):</a:t>
             </a:r>
             <a:br/>
             <a:r>
-              <a:t>para responder a satisfacción todas las preguntas técnicas del jurado.</a:t>
-            </a:r>
-          </a:p>
+              <a:t>  Código sistema, periodo (YYYYMM), RUC supervisora y mesa reguladora BCRP.</a:t>
+            </a:r>
+          </a:p>
+          <a:p>
+            <a:pPr algn="left">
+              <a:spcAft>
+                <a:spcPts val="400"/>
+              </a:spcAft>
+              <a:defRPr sz="950">
+                <a:solidFill>
+                  <a:srgbClr val="334155"/>
+                </a:solidFill>
+                <a:latin typeface="Calibri"/>
+              </a:defRPr>
+            </a:pPr>
+            <a:r>
+              <a:t>• Segmento 02 (Detalle Contingencias):</a:t>
+            </a:r>
+            <a:br/>
+            <a:r>
+              <a:t>  Correlativo ticket, entidad afectada, tipo evento, timestamps y duración min.</a:t>
+            </a:r>
+          </a:p>
+          <a:p>
+            <a:pPr algn="left">
+              <a:spcAft>
+                <a:spcPts val="400"/>
+              </a:spcAft>
+              <a:defRPr sz="950">
+                <a:solidFill>
+                  <a:srgbClr val="334155"/>
+                </a:solidFill>
+                <a:latin typeface="Calibri"/>
+              </a:defRPr>
+            </a:pPr>
+            <a:r>
+              <a:t>• Segmento 03 (Pie Criptográfico):</a:t>
+            </a:r>
+            <a:br/>
+            <a:r>
+              <a:t>  Total registros, minutos sumados y firma digital SHA-256 de 64 hex.</a:t>
+            </a:r>
+          </a:p>
+          <a:p>
+            <a:pPr algn="left">
+              <a:spcAft>
+                <a:spcPts val="400"/>
+              </a:spcAft>
+              <a:defRPr sz="950">
+                <a:solidFill>
+                  <a:srgbClr val="334155"/>
+                </a:solidFill>
+                <a:latin typeface="Calibri"/>
+              </a:defRPr>
+            </a:pPr>
+            <a:r>
+              <a:t>• Garantía de No Repudio:</a:t>
+            </a:r>
+            <a:br/>
+            <a:r>
+              <a:t>  Cualquier alteración en el TXT invalida el hash criptográfico del pie.</a:t>
+            </a:r>
+          </a:p>
+        </p:txBody>
+      </p:sp>
+      <p:sp>
+        <p:nvSpPr>
+          <p:cNvPr id="8" name="Rounded Rectangle 7"/>
+          <p:cNvSpPr/>
+          <p:nvPr/>
+        </p:nvSpPr>
+        <p:spPr>
+          <a:xfrm>
+            <a:off x="8046720" y="1417320"/>
+            <a:ext cx="3410712" cy="5074920"/>
+          </a:xfrm>
+          <a:prstGeom prst="roundRect">
+            <a:avLst/>
+          </a:prstGeom>
+          <a:solidFill>
+            <a:srgbClr val="FFFFFF"/>
+          </a:solidFill>
+          <a:ln w="12700">
+            <a:solidFill>
+              <a:srgbClr val="E2E8F0"/>
+            </a:solidFill>
+          </a:ln>
+        </p:spPr>
+        <p:style>
+          <a:lnRef idx="1">
+            <a:schemeClr val="accent1"/>
+          </a:lnRef>
+          <a:fillRef idx="3">
+            <a:schemeClr val="accent1"/>
+          </a:fillRef>
+          <a:effectRef idx="2">
+            <a:schemeClr val="accent1"/>
+          </a:effectRef>
+          <a:fontRef idx="minor">
+            <a:schemeClr val="lt1"/>
+          </a:fontRef>
+        </p:style>
+        <p:txBody>
+          <a:bodyPr rtlCol="0" anchor="ctr" wrap="square" lIns="182880" rIns="182880" tIns="182880" bIns="137160"/>
+          <a:lstStyle/>
           <a:p>
             <a:pPr algn="ctr">
-              <a:defRPr sz="1300" b="1">
+              <a:spcAft>
+                <a:spcPts val="200"/>
+              </a:spcAft>
+              <a:defRPr sz="1050" b="1">
+                <a:solidFill>
+                  <a:srgbClr val="0284C7"/>
+                </a:solidFill>
+                <a:latin typeface="Calibri"/>
+              </a:defRPr>
+            </a:pPr>
+            <a:r>
+              <a:t>ARQUITECTURA API REST</a:t>
+            </a:r>
+          </a:p>
+          <a:p>
+            <a:pPr algn="ctr">
+              <a:spcAft>
+                <a:spcPts val="300"/>
+              </a:spcAft>
+              <a:defRPr sz="1250" b="1">
+                <a:solidFill>
+                  <a:srgbClr val="0B1F3A"/>
+                </a:solidFill>
+                <a:latin typeface="Calibri"/>
+              </a:defRPr>
+            </a:pPr>
+            <a:r>
+              <a:t>Endpoints Analíticos</a:t>
+            </a:r>
+          </a:p>
+          <a:p>
+            <a:pPr algn="ctr">
+              <a:spcAft>
+                <a:spcPts val="600"/>
+              </a:spcAft>
+              <a:defRPr sz="1000" b="1">
+                <a:solidFill>
+                  <a:srgbClr val="475569"/>
+                </a:solidFill>
+                <a:latin typeface="Calibri"/>
+              </a:defRPr>
+            </a:pPr>
+            <a:r>
+              <a:t>Integración Consola NOC &amp; Swagger</a:t>
+            </a:r>
+          </a:p>
+          <a:p>
+            <a:pPr algn="left">
+              <a:spcAft>
+                <a:spcPts val="400"/>
+              </a:spcAft>
+              <a:defRPr sz="950">
                 <a:solidFill>
                   <a:srgbClr val="334155"/>
                 </a:solidFill>
@@ -5981,11 +8499,71 @@
               </a:defRPr>
             </a:pPr>
             <a:r>
-              <a:t>Frank Vargas (Líder Técnico)  •  Fernando Romero  •  Joel Olaya  •  Luis Tapia</a:t>
+              <a:t>• GET /api/reportes/indisponibilidad:</a:t>
             </a:r>
             <a:br/>
             <a:r>
-              <a:t>Sección 57524 • 2026</a:t>
+              <a:t>  Consolidado mensual con filtros por entidad, rango de fechas y severidad.</a:t>
+            </a:r>
+          </a:p>
+          <a:p>
+            <a:pPr algn="left">
+              <a:spcAft>
+                <a:spcPts val="400"/>
+              </a:spcAft>
+              <a:defRPr sz="950">
+                <a:solidFill>
+                  <a:srgbClr val="334155"/>
+                </a:solidFill>
+                <a:latin typeface="Calibri"/>
+              </a:defRPr>
+            </a:pPr>
+            <a:r>
+              <a:t>• GET /api/reportes/kpis-dashboard:</a:t>
+            </a:r>
+            <a:br/>
+            <a:r>
+              <a:t>  Uptime global, incidentes activos y estado de salud en tiempo real.</a:t>
+            </a:r>
+          </a:p>
+          <a:p>
+            <a:pPr algn="left">
+              <a:spcAft>
+                <a:spcPts val="400"/>
+              </a:spcAft>
+              <a:defRPr sz="950">
+                <a:solidFill>
+                  <a:srgbClr val="334155"/>
+                </a:solidFill>
+                <a:latin typeface="Calibri"/>
+              </a:defRPr>
+            </a:pPr>
+            <a:r>
+              <a:t>• GET /api/reportes/sft/compilar:</a:t>
+            </a:r>
+            <a:br/>
+            <a:r>
+              <a:t>  Generación atómica y descarga del archivo plano listo para mesa BCRP.</a:t>
+            </a:r>
+          </a:p>
+          <a:p>
+            <a:pPr algn="left">
+              <a:spcAft>
+                <a:spcPts val="400"/>
+              </a:spcAft>
+              <a:defRPr sz="950">
+                <a:solidFill>
+                  <a:srgbClr val="334155"/>
+                </a:solidFill>
+                <a:latin typeface="Calibri"/>
+              </a:defRPr>
+            </a:pPr>
+            <a:r>
+              <a:t>• Documentación OpenAPI 3.0:</a:t>
+            </a:r>
+            <a:br/>
+            <a:r>
+              <a:t>  100% testeable en /swagger-ui.html.</a:t>
             </a:r>
           </a:p>
         </p:txBody>
@@ -6666,6 +9244,727 @@
 </p:sld>
 </file>
 
+<file path=ppt/slides/slide20.xml><?xml version="1.0" encoding="utf-8"?>
+<p:sld xmlns:a="http://schemas.openxmlformats.org/drawingml/2006/main" xmlns:p="http://schemas.openxmlformats.org/presentationml/2006/main" xmlns:r="http://schemas.openxmlformats.org/officeDocument/2006/relationships">
+  <p:cSld>
+    <p:spTree>
+      <p:nvGrpSpPr>
+        <p:cNvPr id="1" name=""/>
+        <p:cNvGrpSpPr/>
+        <p:nvPr/>
+      </p:nvGrpSpPr>
+      <p:grpSpPr/>
+      <p:sp>
+        <p:nvSpPr>
+          <p:cNvPr id="2" name="Rectangle 1"/>
+          <p:cNvSpPr/>
+          <p:nvPr/>
+        </p:nvSpPr>
+        <p:spPr>
+          <a:xfrm>
+            <a:off x="0" y="0"/>
+            <a:ext cx="12191695" cy="6858000"/>
+          </a:xfrm>
+          <a:prstGeom prst="rect">
+            <a:avLst/>
+          </a:prstGeom>
+          <a:solidFill>
+            <a:srgbClr val="F8FAFC"/>
+          </a:solidFill>
+          <a:ln>
+            <a:noFill/>
+          </a:ln>
+        </p:spPr>
+        <p:style>
+          <a:lnRef idx="1">
+            <a:schemeClr val="accent1"/>
+          </a:lnRef>
+          <a:fillRef idx="3">
+            <a:schemeClr val="accent1"/>
+          </a:fillRef>
+          <a:effectRef idx="2">
+            <a:schemeClr val="accent1"/>
+          </a:effectRef>
+          <a:fontRef idx="minor">
+            <a:schemeClr val="lt1"/>
+          </a:fontRef>
+        </p:style>
+        <p:txBody>
+          <a:bodyPr rtlCol="0" anchor="ctr"/>
+          <a:lstStyle/>
+          <a:p>
+            <a:pPr algn="ctr"/>
+          </a:p>
+        </p:txBody>
+      </p:sp>
+      <p:sp>
+        <p:nvSpPr>
+          <p:cNvPr id="3" name="Rounded Rectangle 2"/>
+          <p:cNvSpPr/>
+          <p:nvPr/>
+        </p:nvSpPr>
+        <p:spPr>
+          <a:xfrm>
+            <a:off x="731520" y="320040"/>
+            <a:ext cx="10728655" cy="987552"/>
+          </a:xfrm>
+          <a:prstGeom prst="roundRect">
+            <a:avLst/>
+          </a:prstGeom>
+          <a:solidFill>
+            <a:srgbClr val="FFFFFF"/>
+          </a:solidFill>
+          <a:ln w="12700">
+            <a:solidFill>
+              <a:srgbClr val="E2E8F0"/>
+            </a:solidFill>
+          </a:ln>
+        </p:spPr>
+        <p:style>
+          <a:lnRef idx="1">
+            <a:schemeClr val="accent1"/>
+          </a:lnRef>
+          <a:fillRef idx="3">
+            <a:schemeClr val="accent1"/>
+          </a:fillRef>
+          <a:effectRef idx="2">
+            <a:schemeClr val="accent1"/>
+          </a:effectRef>
+          <a:fontRef idx="minor">
+            <a:schemeClr val="lt1"/>
+          </a:fontRef>
+        </p:style>
+        <p:txBody>
+          <a:bodyPr rtlCol="0" anchor="ctr"/>
+          <a:lstStyle/>
+          <a:p>
+            <a:pPr algn="ctr"/>
+          </a:p>
+        </p:txBody>
+      </p:sp>
+      <p:sp>
+        <p:nvSpPr>
+          <p:cNvPr id="4" name="Rounded Rectangle 3"/>
+          <p:cNvSpPr/>
+          <p:nvPr/>
+        </p:nvSpPr>
+        <p:spPr>
+          <a:xfrm>
+            <a:off x="731520" y="320040"/>
+            <a:ext cx="128016" cy="987552"/>
+          </a:xfrm>
+          <a:prstGeom prst="roundRect">
+            <a:avLst/>
+          </a:prstGeom>
+          <a:solidFill>
+            <a:srgbClr val="0284C7"/>
+          </a:solidFill>
+          <a:ln>
+            <a:noFill/>
+          </a:ln>
+        </p:spPr>
+        <p:style>
+          <a:lnRef idx="1">
+            <a:schemeClr val="accent1"/>
+          </a:lnRef>
+          <a:fillRef idx="3">
+            <a:schemeClr val="accent1"/>
+          </a:fillRef>
+          <a:effectRef idx="2">
+            <a:schemeClr val="accent1"/>
+          </a:effectRef>
+          <a:fontRef idx="minor">
+            <a:schemeClr val="lt1"/>
+          </a:fontRef>
+        </p:style>
+        <p:txBody>
+          <a:bodyPr rtlCol="0" anchor="ctr"/>
+          <a:lstStyle/>
+          <a:p>
+            <a:pPr algn="ctr"/>
+          </a:p>
+        </p:txBody>
+      </p:sp>
+      <p:sp>
+        <p:nvSpPr>
+          <p:cNvPr id="5" name="TextBox 4"/>
+          <p:cNvSpPr txBox="1"/>
+          <p:nvPr/>
+        </p:nvSpPr>
+        <p:spPr>
+          <a:xfrm>
+            <a:off x="1051560" y="347472"/>
+            <a:ext cx="10149840" cy="914400"/>
+          </a:xfrm>
+          <a:prstGeom prst="rect">
+            <a:avLst/>
+          </a:prstGeom>
+          <a:noFill/>
+        </p:spPr>
+        <p:txBody>
+          <a:bodyPr wrap="square" lIns="0" tIns="0" rIns="0" bIns="0">
+            <a:spAutoFit/>
+          </a:bodyPr>
+          <a:lstStyle/>
+          <a:p>
+            <a:pPr>
+              <a:defRPr sz="1100" b="1">
+                <a:solidFill>
+                  <a:srgbClr val="0284C7"/>
+                </a:solidFill>
+                <a:latin typeface="Calibri"/>
+              </a:defRPr>
+            </a:pPr>
+            <a:r>
+              <a:t>SUSTENTACIÓN ORAL APF2 • RÚBRICA 20/20</a:t>
+            </a:r>
+          </a:p>
+          <a:p>
+            <a:pPr>
+              <a:defRPr sz="1600" b="1">
+                <a:solidFill>
+                  <a:srgbClr val="0F172A"/>
+                </a:solidFill>
+                <a:latin typeface="Calibri"/>
+              </a:defRPr>
+            </a:pPr>
+            <a:r>
+              <a:t>Defensa Ejecutiva: Guion de 10 Minutos Equitativo (Solo 3 Integrantes)</a:t>
+            </a:r>
+          </a:p>
+          <a:p>
+            <a:pPr>
+              <a:defRPr sz="1050">
+                <a:solidFill>
+                  <a:srgbClr val="64748B"/>
+                </a:solidFill>
+                <a:latin typeface="Calibri"/>
+              </a:defRPr>
+            </a:pPr>
+            <a:r>
+              <a:t>Distribución estratégica del tiempo para la presentación ante el jurado e Ing. Yony Zamata Condori</a:t>
+            </a:r>
+          </a:p>
+        </p:txBody>
+      </p:sp>
+      <p:sp>
+        <p:nvSpPr>
+          <p:cNvPr id="6" name="Rounded Rectangle 5"/>
+          <p:cNvSpPr/>
+          <p:nvPr/>
+        </p:nvSpPr>
+        <p:spPr>
+          <a:xfrm>
+            <a:off x="731520" y="1417320"/>
+            <a:ext cx="3410712" cy="5074920"/>
+          </a:xfrm>
+          <a:prstGeom prst="roundRect">
+            <a:avLst/>
+          </a:prstGeom>
+          <a:solidFill>
+            <a:srgbClr val="FFFFFF"/>
+          </a:solidFill>
+          <a:ln w="12700">
+            <a:solidFill>
+              <a:srgbClr val="E2E8F0"/>
+            </a:solidFill>
+          </a:ln>
+        </p:spPr>
+        <p:style>
+          <a:lnRef idx="1">
+            <a:schemeClr val="accent1"/>
+          </a:lnRef>
+          <a:fillRef idx="3">
+            <a:schemeClr val="accent1"/>
+          </a:fillRef>
+          <a:effectRef idx="2">
+            <a:schemeClr val="accent1"/>
+          </a:effectRef>
+          <a:fontRef idx="minor">
+            <a:schemeClr val="lt1"/>
+          </a:fontRef>
+        </p:style>
+        <p:txBody>
+          <a:bodyPr rtlCol="0" anchor="ctr" wrap="square" lIns="182880" rIns="182880" tIns="182880" bIns="137160"/>
+          <a:lstStyle/>
+          <a:p>
+            <a:pPr algn="ctr">
+              <a:spcAft>
+                <a:spcPts val="200"/>
+              </a:spcAft>
+              <a:defRPr sz="1050" b="1">
+                <a:solidFill>
+                  <a:srgbClr val="0284C7"/>
+                </a:solidFill>
+                <a:latin typeface="Calibri"/>
+              </a:defRPr>
+            </a:pPr>
+            <a:r>
+              <a:t>BLOQUE 1 • 00:00 - 03:00</a:t>
+            </a:r>
+          </a:p>
+          <a:p>
+            <a:pPr algn="ctr">
+              <a:spcAft>
+                <a:spcPts val="300"/>
+              </a:spcAft>
+              <a:defRPr sz="1250" b="1">
+                <a:solidFill>
+                  <a:srgbClr val="0B1F3A"/>
+                </a:solidFill>
+                <a:latin typeface="Calibri"/>
+              </a:defRPr>
+            </a:pPr>
+            <a:r>
+              <a:t>Fernando Romero</a:t>
+            </a:r>
+          </a:p>
+          <a:p>
+            <a:pPr algn="ctr">
+              <a:spcAft>
+                <a:spcPts val="600"/>
+              </a:spcAft>
+              <a:defRPr sz="1000" b="1">
+                <a:solidFill>
+                  <a:srgbClr val="475569"/>
+                </a:solidFill>
+                <a:latin typeface="Calibri"/>
+              </a:defRPr>
+            </a:pPr>
+            <a:r>
+              <a:t>Ingeniero de Requisitos &amp; Procesos</a:t>
+            </a:r>
+          </a:p>
+          <a:p>
+            <a:pPr algn="left">
+              <a:spcAft>
+                <a:spcPts val="400"/>
+              </a:spcAft>
+              <a:defRPr sz="950">
+                <a:solidFill>
+                  <a:srgbClr val="334155"/>
+                </a:solidFill>
+                <a:latin typeface="Calibri"/>
+              </a:defRPr>
+            </a:pPr>
+            <a:r>
+              <a:t>• Marco Institucional del BCRP:</a:t>
+            </a:r>
+            <a:br/>
+            <a:r>
+              <a:t>  Leyes N° 26123 y N° 29440 sobre el Sistema Nacional de Pagos.</a:t>
+            </a:r>
+          </a:p>
+          <a:p>
+            <a:pPr algn="left">
+              <a:spcAft>
+                <a:spcPts val="400"/>
+              </a:spcAft>
+              <a:defRPr sz="950">
+                <a:solidFill>
+                  <a:srgbClr val="334155"/>
+                </a:solidFill>
+                <a:latin typeface="Calibri"/>
+              </a:defRPr>
+            </a:pPr>
+            <a:r>
+              <a:t>• Circular BCRP N° 0011-2023:</a:t>
+            </a:r>
+            <a:br/>
+            <a:r>
+              <a:t>  Interoperabilidad de pagos (Yape, Plim, Tunki, CCE) y contingencias.</a:t>
+            </a:r>
+          </a:p>
+          <a:p>
+            <a:pPr algn="left">
+              <a:spcAft>
+                <a:spcPts val="400"/>
+              </a:spcAft>
+              <a:defRPr sz="950">
+                <a:solidFill>
+                  <a:srgbClr val="334155"/>
+                </a:solidFill>
+                <a:latin typeface="Calibri"/>
+              </a:defRPr>
+            </a:pPr>
+            <a:r>
+              <a:t>• Problemática Real:</a:t>
+            </a:r>
+            <a:br/>
+            <a:r>
+              <a:t>  Asimetría informativa y demoras de hasta 180 min ante caídas bancarias.</a:t>
+            </a:r>
+          </a:p>
+          <a:p>
+            <a:pPr algn="left">
+              <a:spcAft>
+                <a:spcPts val="400"/>
+              </a:spcAft>
+              <a:defRPr sz="950">
+                <a:solidFill>
+                  <a:srgbClr val="334155"/>
+                </a:solidFill>
+                <a:latin typeface="Calibri"/>
+              </a:defRPr>
+            </a:pPr>
+            <a:r>
+              <a:t>• Propuesta de Valor BMC:</a:t>
+            </a:r>
+            <a:br/>
+            <a:r>
+              <a:t>  Detección telemétrica en &lt; 30 seg, trazabilidad y observabilidad pública.</a:t>
+            </a:r>
+          </a:p>
+        </p:txBody>
+      </p:sp>
+      <p:sp>
+        <p:nvSpPr>
+          <p:cNvPr id="7" name="Rounded Rectangle 6"/>
+          <p:cNvSpPr/>
+          <p:nvPr/>
+        </p:nvSpPr>
+        <p:spPr>
+          <a:xfrm>
+            <a:off x="4389120" y="1417320"/>
+            <a:ext cx="3410712" cy="5074920"/>
+          </a:xfrm>
+          <a:prstGeom prst="roundRect">
+            <a:avLst/>
+          </a:prstGeom>
+          <a:solidFill>
+            <a:srgbClr val="FFFFFF"/>
+          </a:solidFill>
+          <a:ln w="12700">
+            <a:solidFill>
+              <a:srgbClr val="E2E8F0"/>
+            </a:solidFill>
+          </a:ln>
+        </p:spPr>
+        <p:style>
+          <a:lnRef idx="1">
+            <a:schemeClr val="accent1"/>
+          </a:lnRef>
+          <a:fillRef idx="3">
+            <a:schemeClr val="accent1"/>
+          </a:fillRef>
+          <a:effectRef idx="2">
+            <a:schemeClr val="accent1"/>
+          </a:effectRef>
+          <a:fontRef idx="minor">
+            <a:schemeClr val="lt1"/>
+          </a:fontRef>
+        </p:style>
+        <p:txBody>
+          <a:bodyPr rtlCol="0" anchor="ctr" wrap="square" lIns="182880" rIns="182880" tIns="182880" bIns="137160"/>
+          <a:lstStyle/>
+          <a:p>
+            <a:pPr algn="ctr">
+              <a:spcAft>
+                <a:spcPts val="200"/>
+              </a:spcAft>
+              <a:defRPr sz="1050" b="1">
+                <a:solidFill>
+                  <a:srgbClr val="0284C7"/>
+                </a:solidFill>
+                <a:latin typeface="Calibri"/>
+              </a:defRPr>
+            </a:pPr>
+            <a:r>
+              <a:t>BLOQUE 2 • 03:00 - 07:00</a:t>
+            </a:r>
+          </a:p>
+          <a:p>
+            <a:pPr algn="ctr">
+              <a:spcAft>
+                <a:spcPts val="300"/>
+              </a:spcAft>
+              <a:defRPr sz="1250" b="1">
+                <a:solidFill>
+                  <a:srgbClr val="0B1F3A"/>
+                </a:solidFill>
+                <a:latin typeface="Calibri"/>
+              </a:defRPr>
+            </a:pPr>
+            <a:r>
+              <a:t>Frank Vargas</a:t>
+            </a:r>
+          </a:p>
+          <a:p>
+            <a:pPr algn="ctr">
+              <a:spcAft>
+                <a:spcPts val="600"/>
+              </a:spcAft>
+              <a:defRPr sz="1000" b="1">
+                <a:solidFill>
+                  <a:srgbClr val="475569"/>
+                </a:solidFill>
+                <a:latin typeface="Calibri"/>
+              </a:defRPr>
+            </a:pPr>
+            <a:r>
+              <a:t>Líder Técnico &amp; Arquitecto de Software</a:t>
+            </a:r>
+          </a:p>
+          <a:p>
+            <a:pPr algn="left">
+              <a:spcAft>
+                <a:spcPts val="400"/>
+              </a:spcAft>
+              <a:defRPr sz="950">
+                <a:solidFill>
+                  <a:srgbClr val="334155"/>
+                </a:solidFill>
+                <a:latin typeface="Calibri"/>
+              </a:defRPr>
+            </a:pPr>
+            <a:r>
+              <a:t>• 3 Alternativas TIC (&gt;= 50% Java):</a:t>
+            </a:r>
+            <a:br/>
+            <a:r>
+              <a:t>  Justificación de la Alternativa 2 (Clean API + SPA NOC) con 4.97 pts.</a:t>
+            </a:r>
+          </a:p>
+          <a:p>
+            <a:pPr algn="left">
+              <a:spcAft>
+                <a:spcPts val="400"/>
+              </a:spcAft>
+              <a:defRPr sz="950">
+                <a:solidFill>
+                  <a:srgbClr val="334155"/>
+                </a:solidFill>
+                <a:latin typeface="Calibri"/>
+              </a:defRPr>
+            </a:pPr>
+            <a:r>
+              <a:t>• Galería de 15 Mockups:</a:t>
+            </a:r>
+            <a:br/>
+            <a:r>
+              <a:t>  Demostración de los 5 paneles diseñados por cada alternativa.</a:t>
+            </a:r>
+          </a:p>
+          <a:p>
+            <a:pPr algn="left">
+              <a:spcAft>
+                <a:spcPts val="400"/>
+              </a:spcAft>
+              <a:defRPr sz="950">
+                <a:solidFill>
+                  <a:srgbClr val="334155"/>
+                </a:solidFill>
+                <a:latin typeface="Calibri"/>
+              </a:defRPr>
+            </a:pPr>
+            <a:r>
+              <a:t>• Persistencia DER PostgreSQL 15:</a:t>
+            </a:r>
+            <a:br/>
+            <a:r>
+              <a:t>  6 tablas normalizadas, triggers append-only e índice anti-carreras.</a:t>
+            </a:r>
+          </a:p>
+          <a:p>
+            <a:pPr algn="left">
+              <a:spcAft>
+                <a:spcPts val="400"/>
+              </a:spcAft>
+              <a:defRPr sz="950">
+                <a:solidFill>
+                  <a:srgbClr val="334155"/>
+                </a:solidFill>
+                <a:latin typeface="Calibri"/>
+              </a:defRPr>
+            </a:pPr>
+            <a:r>
+              <a:t>• Clases de Diseño en Spring Boot 3:</a:t>
+            </a:r>
+            <a:br/>
+            <a:r>
+              <a:t>  Inyección de dependencias, desacoplamiento hexagonal y seguridad RBAC.</a:t>
+            </a:r>
+          </a:p>
+        </p:txBody>
+      </p:sp>
+      <p:sp>
+        <p:nvSpPr>
+          <p:cNvPr id="8" name="Rounded Rectangle 7"/>
+          <p:cNvSpPr/>
+          <p:nvPr/>
+        </p:nvSpPr>
+        <p:spPr>
+          <a:xfrm>
+            <a:off x="8046720" y="1417320"/>
+            <a:ext cx="3410712" cy="5074920"/>
+          </a:xfrm>
+          <a:prstGeom prst="roundRect">
+            <a:avLst/>
+          </a:prstGeom>
+          <a:solidFill>
+            <a:srgbClr val="FFFFFF"/>
+          </a:solidFill>
+          <a:ln w="12700">
+            <a:solidFill>
+              <a:srgbClr val="E2E8F0"/>
+            </a:solidFill>
+          </a:ln>
+        </p:spPr>
+        <p:style>
+          <a:lnRef idx="1">
+            <a:schemeClr val="accent1"/>
+          </a:lnRef>
+          <a:fillRef idx="3">
+            <a:schemeClr val="accent1"/>
+          </a:fillRef>
+          <a:effectRef idx="2">
+            <a:schemeClr val="accent1"/>
+          </a:effectRef>
+          <a:fontRef idx="minor">
+            <a:schemeClr val="lt1"/>
+          </a:fontRef>
+        </p:style>
+        <p:txBody>
+          <a:bodyPr rtlCol="0" anchor="ctr" wrap="square" lIns="182880" rIns="182880" tIns="182880" bIns="137160"/>
+          <a:lstStyle/>
+          <a:p>
+            <a:pPr algn="ctr">
+              <a:spcAft>
+                <a:spcPts val="200"/>
+              </a:spcAft>
+              <a:defRPr sz="1050" b="1">
+                <a:solidFill>
+                  <a:srgbClr val="0284C7"/>
+                </a:solidFill>
+                <a:latin typeface="Calibri"/>
+              </a:defRPr>
+            </a:pPr>
+            <a:r>
+              <a:t>BLOQUE 3 • 07:00 - 10:00</a:t>
+            </a:r>
+          </a:p>
+          <a:p>
+            <a:pPr algn="ctr">
+              <a:spcAft>
+                <a:spcPts val="300"/>
+              </a:spcAft>
+              <a:defRPr sz="1250" b="1">
+                <a:solidFill>
+                  <a:srgbClr val="0B1F3A"/>
+                </a:solidFill>
+                <a:latin typeface="Calibri"/>
+              </a:defRPr>
+            </a:pPr>
+            <a:r>
+              <a:t>Joel Olaya</a:t>
+            </a:r>
+          </a:p>
+          <a:p>
+            <a:pPr algn="ctr">
+              <a:spcAft>
+                <a:spcPts val="600"/>
+              </a:spcAft>
+              <a:defRPr sz="1000" b="1">
+                <a:solidFill>
+                  <a:srgbClr val="475569"/>
+                </a:solidFill>
+                <a:latin typeface="Calibri"/>
+              </a:defRPr>
+            </a:pPr>
+            <a:r>
+              <a:t>Ingeniero de Software &amp; QA</a:t>
+            </a:r>
+          </a:p>
+          <a:p>
+            <a:pPr algn="left">
+              <a:spcAft>
+                <a:spcPts val="400"/>
+              </a:spcAft>
+              <a:defRPr sz="950">
+                <a:solidFill>
+                  <a:srgbClr val="334155"/>
+                </a:solidFill>
+                <a:latin typeface="Calibri"/>
+              </a:defRPr>
+            </a:pPr>
+            <a:r>
+              <a:t>• Live Demo Consola NOC Web:</a:t>
+            </a:r>
+            <a:br/>
+            <a:r>
+              <a:t>  Login AD, barra de telemetría en vivo e inyección de contingencia 503.</a:t>
+            </a:r>
+          </a:p>
+          <a:p>
+            <a:pPr algn="left">
+              <a:spcAft>
+                <a:spcPts val="400"/>
+              </a:spcAft>
+              <a:defRPr sz="950">
+                <a:solidFill>
+                  <a:srgbClr val="334155"/>
+                </a:solidFill>
+                <a:latin typeface="Calibri"/>
+              </a:defRPr>
+            </a:pPr>
+            <a:r>
+              <a:t>• Creación Atómica de Incidentes:</a:t>
+            </a:r>
+            <a:br/>
+            <a:r>
+              <a:t>  Generación de ticket INC-YYYYMMDD-XXXXX y semáforo rojo en 30 seg.</a:t>
+            </a:r>
+          </a:p>
+          <a:p>
+            <a:pPr algn="left">
+              <a:spcAft>
+                <a:spcPts val="400"/>
+              </a:spcAft>
+              <a:defRPr sz="950">
+                <a:solidFill>
+                  <a:srgbClr val="334155"/>
+                </a:solidFill>
+                <a:latin typeface="Calibri"/>
+              </a:defRPr>
+            </a:pPr>
+            <a:r>
+              <a:t>• Suite Automatizada JUnit 5:</a:t>
+            </a:r>
+            <a:br/>
+            <a:r>
+              <a:t>  8/8 pruebas unitarias pasadas con Mockito en 4.8 segundos.</a:t>
+            </a:r>
+          </a:p>
+          <a:p>
+            <a:pPr algn="left">
+              <a:spcAft>
+                <a:spcPts val="400"/>
+              </a:spcAft>
+              <a:defRPr sz="950">
+                <a:solidFill>
+                  <a:srgbClr val="334155"/>
+                </a:solidFill>
+                <a:latin typeface="Calibri"/>
+              </a:defRPr>
+            </a:pPr>
+            <a:r>
+              <a:t>• Compilador Normativo SFT BCRP:</a:t>
+            </a:r>
+            <a:br/>
+            <a:r>
+              <a:t>  Generación del reporte de indisponibilidad y sellado criptográfico SHA-256.</a:t>
+            </a:r>
+          </a:p>
+        </p:txBody>
+      </p:sp>
+    </p:spTree>
+  </p:cSld>
+  <p:clrMapOvr>
+    <a:masterClrMapping/>
+  </p:clrMapOvr>
+</p:sld>
+</file>
+
 <file path=ppt/slides/slide3.xml><?xml version="1.0" encoding="utf-8"?>
 <p:sld xmlns:a="http://schemas.openxmlformats.org/drawingml/2006/main" xmlns:p="http://schemas.openxmlformats.org/presentationml/2006/main" xmlns:r="http://schemas.openxmlformats.org/officeDocument/2006/relationships">
   <p:cSld>
@@ -8351,7 +11650,7 @@
               </a:defRPr>
             </a:pPr>
             <a:r>
-              <a:t>Frank Emiliano Vargas Huamán (Líder Técnico):</a:t>
+              <a:t>Frank Emiliano Vargas Huamán (Líder Técnico &amp; Arquitecto):</a:t>
             </a:r>
           </a:p>
           <a:p>
@@ -8367,11 +11666,7 @@
               </a:defRPr>
             </a:pPr>
             <a:r>
-              <a:t>• Accountable (A) en Arquitectura Hexagonal y DDL SQL.</a:t>
-            </a:r>
-            <a:br/>
-            <a:r>
-              <a:t>• Responsible (R) en Backend Java 17, Spring Boot 3 y Docker.</a:t>
+              <a:t>• Accountable (A) y Responsible (R) en Arquitectura Hexagonal, Modelado DDL PostgreSQL 15, Core Java 17, Spring Boot 3 y Docker Compose.</a:t>
             </a:r>
           </a:p>
           <a:p>
@@ -8387,7 +11682,7 @@
               </a:defRPr>
             </a:pPr>
             <a:r>
-              <a:t>Fernando Alber Alfredo Romero Requejo:</a:t>
+              <a:t>Fernando Alber Alfredo Romero Requejo (Ingeniero de Requisitos):</a:t>
             </a:r>
           </a:p>
           <a:p>
@@ -8403,11 +11698,7 @@
               </a:defRPr>
             </a:pPr>
             <a:r>
-              <a:t>• Responsible (R) en Levantamiento SRS IEEE 830 y BPMN.</a:t>
-            </a:r>
-            <a:br/>
-            <a:r>
-              <a:t>• Consulted (C) en Casos de Uso y Reglas de Negocio.</a:t>
+              <a:t>• Responsible (R) en Levantamiento SRS IEEE 830 y Procesos BPMN 2.0. • Consulted (C) en Casos de Uso UML 2.5 y Reglas Normativas BCRP.</a:t>
             </a:r>
           </a:p>
           <a:p>
@@ -8423,7 +11714,7 @@
               </a:defRPr>
             </a:pPr>
             <a:r>
-              <a:t>Joel Leonardo Olaya Vivas:</a:t>
+              <a:t>Joel Leonardo Olaya Vivas (Ingeniero de Software &amp; QA):</a:t>
             </a:r>
           </a:p>
           <a:p>
@@ -8439,47 +11730,7 @@
               </a:defRPr>
             </a:pPr>
             <a:r>
-              <a:t>• Responsible (R) en Suite de Pruebas Unitarias JUnit 5.</a:t>
-            </a:r>
-            <a:br/>
-            <a:r>
-              <a:t>• Consulted (C) en Pruebas de Carga y Validación QA.</a:t>
-            </a:r>
-          </a:p>
-          <a:p>
-            <a:pPr>
-              <a:spcAft>
-                <a:spcPts val="200"/>
-              </a:spcAft>
-              <a:defRPr sz="1300" b="1">
-                <a:solidFill>
-                  <a:srgbClr val="0B1F3A"/>
-                </a:solidFill>
-                <a:latin typeface="Calibri"/>
-              </a:defRPr>
-            </a:pPr>
-            <a:r>
-              <a:t>Luis Tapia Ignacio:</a:t>
-            </a:r>
-          </a:p>
-          <a:p>
-            <a:pPr>
-              <a:spcAft>
-                <a:spcPts val="600"/>
-              </a:spcAft>
-              <a:defRPr sz="1200">
-                <a:solidFill>
-                  <a:srgbClr val="334155"/>
-                </a:solidFill>
-                <a:latin typeface="Calibri"/>
-              </a:defRPr>
-            </a:pPr>
-            <a:r>
-              <a:t>• Responsible (R) en Modelado de Datos y Script DDL Inmutable.</a:t>
-            </a:r>
-            <a:br/>
-            <a:r>
-              <a:t>• Informed (I) en Despliegue y Pruebas en Vivo.</a:t>
+              <a:t>• Responsible (R) en Suite JUnit 5 / Mockito (8/8 tests). • Responsible (R) en Módulo de Reportes de Indisponibilidad y Compilador SFT BCRP con SHA-256.</a:t>
             </a:r>
           </a:p>
         </p:txBody>

</xml_diff>